<commit_message>
First finished version (R)
</commit_message>
<xml_diff>
--- a/01R/01_complements.pptx
+++ b/01R/01_complements.pptx
@@ -5,7 +5,7 @@
     <p:sldMasterId id="2147483648" r:id="rId1"/>
   </p:sldMasterIdLst>
   <p:notesMasterIdLst>
-    <p:notesMasterId r:id="rId7"/>
+    <p:notesMasterId r:id="rId11"/>
   </p:notesMasterIdLst>
   <p:sldIdLst>
     <p:sldId id="256" r:id="rId2"/>
@@ -13,6 +13,10 @@
     <p:sldId id="276" r:id="rId4"/>
     <p:sldId id="278" r:id="rId5"/>
     <p:sldId id="277" r:id="rId6"/>
+    <p:sldId id="279" r:id="rId7"/>
+    <p:sldId id="281" r:id="rId8"/>
+    <p:sldId id="280" r:id="rId9"/>
+    <p:sldId id="282" r:id="rId10"/>
   </p:sldIdLst>
   <p:sldSz cx="12192000" cy="6858000"/>
   <p:notesSz cx="6858000" cy="9144000"/>
@@ -111,6 +115,11 @@
       </a:defRPr>
     </a:lvl9pPr>
   </p:defaultTextStyle>
+  <p:extLst>
+    <p:ext uri="{EFAFB233-063F-42B5-8137-9DF3F51BA10A}">
+      <p15:sldGuideLst xmlns:p15="http://schemas.microsoft.com/office/powerpoint/2012/main"/>
+    </p:ext>
+  </p:extLst>
 </p:presentation>
 </file>
 
@@ -196,7 +205,7 @@
           <a:p>
             <a:fld id="{5687CA22-74B5-674B-86F1-22F42745F9A6}" type="datetimeFigureOut">
               <a:rPr lang="fr-FR" smtClean="0"/>
-              <a:t>26/05/2025</a:t>
+              <a:t>31/05/2025</a:t>
             </a:fld>
             <a:endParaRPr lang="fr-FR"/>
           </a:p>
@@ -610,7 +619,7 @@
           <a:p>
             <a:fld id="{4970EE25-B4AA-7F4C-A9F6-0BF76B77CD37}" type="datetime1">
               <a:rPr lang="fr-FR" smtClean="0"/>
-              <a:t>26/05/2025</a:t>
+              <a:t>31/05/2025</a:t>
             </a:fld>
             <a:endParaRPr lang="fr-FR"/>
           </a:p>
@@ -808,7 +817,7 @@
           <a:p>
             <a:fld id="{AED2EE47-86AE-CF41-B18A-FCA4D53C0FA0}" type="datetime1">
               <a:rPr lang="fr-FR" smtClean="0"/>
-              <a:t>26/05/2025</a:t>
+              <a:t>31/05/2025</a:t>
             </a:fld>
             <a:endParaRPr lang="fr-FR"/>
           </a:p>
@@ -1016,7 +1025,7 @@
           <a:p>
             <a:fld id="{026750ED-8AC0-0449-8500-715BA1CF1D4B}" type="datetime1">
               <a:rPr lang="fr-FR" smtClean="0"/>
-              <a:t>26/05/2025</a:t>
+              <a:t>31/05/2025</a:t>
             </a:fld>
             <a:endParaRPr lang="fr-FR"/>
           </a:p>
@@ -1214,7 +1223,7 @@
           <a:p>
             <a:fld id="{71BDFCFA-A83A-8C43-9B81-73E6E29FAD10}" type="datetime1">
               <a:rPr lang="fr-FR" smtClean="0"/>
-              <a:t>26/05/2025</a:t>
+              <a:t>31/05/2025</a:t>
             </a:fld>
             <a:endParaRPr lang="fr-FR"/>
           </a:p>
@@ -1489,7 +1498,7 @@
           <a:p>
             <a:fld id="{570CE06D-FF95-C248-92DD-B98526EE7FAE}" type="datetime1">
               <a:rPr lang="fr-FR" smtClean="0"/>
-              <a:t>26/05/2025</a:t>
+              <a:t>31/05/2025</a:t>
             </a:fld>
             <a:endParaRPr lang="fr-FR"/>
           </a:p>
@@ -1754,7 +1763,7 @@
           <a:p>
             <a:fld id="{836DBCE9-507B-9A48-8808-67AAC0AFA35F}" type="datetime1">
               <a:rPr lang="fr-FR" smtClean="0"/>
-              <a:t>26/05/2025</a:t>
+              <a:t>31/05/2025</a:t>
             </a:fld>
             <a:endParaRPr lang="fr-FR"/>
           </a:p>
@@ -2166,7 +2175,7 @@
           <a:p>
             <a:fld id="{6E9925AB-13DF-FD4B-B94E-B8E10EBB4E1B}" type="datetime1">
               <a:rPr lang="fr-FR" smtClean="0"/>
-              <a:t>26/05/2025</a:t>
+              <a:t>31/05/2025</a:t>
             </a:fld>
             <a:endParaRPr lang="fr-FR"/>
           </a:p>
@@ -2307,7 +2316,7 @@
           <a:p>
             <a:fld id="{2EE7C013-61EE-D047-924C-ECB9A6CD7CD5}" type="datetime1">
               <a:rPr lang="fr-FR" smtClean="0"/>
-              <a:t>26/05/2025</a:t>
+              <a:t>31/05/2025</a:t>
             </a:fld>
             <a:endParaRPr lang="fr-FR"/>
           </a:p>
@@ -2420,7 +2429,7 @@
           <a:p>
             <a:fld id="{125AE8DF-E0E5-074A-8C14-707D8E751F96}" type="datetime1">
               <a:rPr lang="fr-FR" smtClean="0"/>
-              <a:t>26/05/2025</a:t>
+              <a:t>31/05/2025</a:t>
             </a:fld>
             <a:endParaRPr lang="fr-FR"/>
           </a:p>
@@ -2731,7 +2740,7 @@
           <a:p>
             <a:fld id="{C45D61FF-8223-EE45-B643-07E3BB6B0D2D}" type="datetime1">
               <a:rPr lang="fr-FR" smtClean="0"/>
-              <a:t>26/05/2025</a:t>
+              <a:t>31/05/2025</a:t>
             </a:fld>
             <a:endParaRPr lang="fr-FR"/>
           </a:p>
@@ -3019,7 +3028,7 @@
           <a:p>
             <a:fld id="{447529C1-66A9-EA4D-80C4-5A5816D9B083}" type="datetime1">
               <a:rPr lang="fr-FR" smtClean="0"/>
-              <a:t>26/05/2025</a:t>
+              <a:t>31/05/2025</a:t>
             </a:fld>
             <a:endParaRPr lang="fr-FR"/>
           </a:p>
@@ -3260,7 +3269,7 @@
           <a:p>
             <a:fld id="{1E9EFE79-A723-4F49-B2DF-9BC02BF17F86}" type="datetime1">
               <a:rPr lang="fr-FR" smtClean="0"/>
-              <a:t>26/05/2025</a:t>
+              <a:t>31/05/2025</a:t>
             </a:fld>
             <a:endParaRPr lang="fr-FR"/>
           </a:p>
@@ -5996,6 +6005,2632 @@
     <p:extLst>
       <p:ext uri="{BB962C8B-B14F-4D97-AF65-F5344CB8AC3E}">
         <p14:creationId xmlns:p14="http://schemas.microsoft.com/office/powerpoint/2010/main" val="1158664206"/>
+      </p:ext>
+    </p:extLst>
+  </p:cSld>
+  <p:clrMapOvr>
+    <a:masterClrMapping/>
+  </p:clrMapOvr>
+</p:sld>
+</file>
+
+<file path=ppt/slides/slide6.xml><?xml version="1.0" encoding="utf-8"?>
+<p:sld xmlns:a="http://schemas.openxmlformats.org/drawingml/2006/main" xmlns:r="http://schemas.openxmlformats.org/officeDocument/2006/relationships" xmlns:p="http://schemas.openxmlformats.org/presentationml/2006/main">
+  <p:cSld>
+    <p:spTree>
+      <p:nvGrpSpPr>
+        <p:cNvPr id="1" name=""/>
+        <p:cNvGrpSpPr/>
+        <p:nvPr/>
+      </p:nvGrpSpPr>
+      <p:grpSpPr>
+        <a:xfrm>
+          <a:off x="0" y="0"/>
+          <a:ext cx="0" cy="0"/>
+          <a:chOff x="0" y="0"/>
+          <a:chExt cx="0" cy="0"/>
+        </a:xfrm>
+      </p:grpSpPr>
+      <p:sp>
+        <p:nvSpPr>
+          <p:cNvPr id="2" name="Titre 1">
+            <a:extLst>
+              <a:ext uri="{FF2B5EF4-FFF2-40B4-BE49-F238E27FC236}">
+                <a16:creationId xmlns:a16="http://schemas.microsoft.com/office/drawing/2014/main" id="{43D931F7-6204-8166-2596-7208D9C41BB3}"/>
+              </a:ext>
+            </a:extLst>
+          </p:cNvPr>
+          <p:cNvSpPr>
+            <a:spLocks noGrp="1"/>
+          </p:cNvSpPr>
+          <p:nvPr>
+            <p:ph type="title"/>
+          </p:nvPr>
+        </p:nvSpPr>
+        <p:spPr/>
+        <p:txBody>
+          <a:bodyPr/>
+          <a:lstStyle/>
+          <a:p>
+            <a:r>
+              <a:rPr lang="en-US" noProof="0" dirty="0" err="1"/>
+              <a:t>pheatmap</a:t>
+            </a:r>
+            <a:r>
+              <a:rPr lang="en-US" noProof="0" dirty="0"/>
+              <a:t>: “Pretty” heatmaps</a:t>
+            </a:r>
+          </a:p>
+        </p:txBody>
+      </p:sp>
+      <p:sp>
+        <p:nvSpPr>
+          <p:cNvPr id="3" name="Espace réservé du texte 2">
+            <a:extLst>
+              <a:ext uri="{FF2B5EF4-FFF2-40B4-BE49-F238E27FC236}">
+                <a16:creationId xmlns:a16="http://schemas.microsoft.com/office/drawing/2014/main" id="{1B0B9505-FC74-E41B-06D5-15BB44EEC054}"/>
+              </a:ext>
+            </a:extLst>
+          </p:cNvPr>
+          <p:cNvSpPr>
+            <a:spLocks noGrp="1"/>
+          </p:cNvSpPr>
+          <p:nvPr>
+            <p:ph type="body" idx="1"/>
+          </p:nvPr>
+        </p:nvSpPr>
+        <p:spPr/>
+        <p:txBody>
+          <a:bodyPr/>
+          <a:lstStyle/>
+          <a:p>
+            <a:endParaRPr lang="fr-FR" dirty="0"/>
+          </a:p>
+        </p:txBody>
+      </p:sp>
+      <p:sp>
+        <p:nvSpPr>
+          <p:cNvPr id="4" name="Espace réservé du numéro de diapositive 3">
+            <a:extLst>
+              <a:ext uri="{FF2B5EF4-FFF2-40B4-BE49-F238E27FC236}">
+                <a16:creationId xmlns:a16="http://schemas.microsoft.com/office/drawing/2014/main" id="{E967C120-74C5-9464-B8A8-DC76CFE218FC}"/>
+              </a:ext>
+            </a:extLst>
+          </p:cNvPr>
+          <p:cNvSpPr>
+            <a:spLocks noGrp="1"/>
+          </p:cNvSpPr>
+          <p:nvPr>
+            <p:ph type="sldNum" sz="quarter" idx="12"/>
+          </p:nvPr>
+        </p:nvSpPr>
+        <p:spPr/>
+        <p:txBody>
+          <a:bodyPr/>
+          <a:lstStyle/>
+          <a:p>
+            <a:fld id="{D13C05C1-FA7E-DB42-9F51-FE4437F6CA80}" type="slidenum">
+              <a:rPr lang="fr-FR" smtClean="0"/>
+              <a:t>5</a:t>
+            </a:fld>
+            <a:endParaRPr lang="fr-FR"/>
+          </a:p>
+        </p:txBody>
+      </p:sp>
+    </p:spTree>
+    <p:extLst>
+      <p:ext uri="{BB962C8B-B14F-4D97-AF65-F5344CB8AC3E}">
+        <p14:creationId xmlns:p14="http://schemas.microsoft.com/office/powerpoint/2010/main" val="4001416430"/>
+      </p:ext>
+    </p:extLst>
+  </p:cSld>
+  <p:clrMapOvr>
+    <a:masterClrMapping/>
+  </p:clrMapOvr>
+</p:sld>
+</file>
+
+<file path=ppt/slides/slide7.xml><?xml version="1.0" encoding="utf-8"?>
+<p:sld xmlns:a="http://schemas.openxmlformats.org/drawingml/2006/main" xmlns:r="http://schemas.openxmlformats.org/officeDocument/2006/relationships" xmlns:p="http://schemas.openxmlformats.org/presentationml/2006/main">
+  <p:cSld>
+    <p:spTree>
+      <p:nvGrpSpPr>
+        <p:cNvPr id="1" name=""/>
+        <p:cNvGrpSpPr/>
+        <p:nvPr/>
+      </p:nvGrpSpPr>
+      <p:grpSpPr>
+        <a:xfrm>
+          <a:off x="0" y="0"/>
+          <a:ext cx="0" cy="0"/>
+          <a:chOff x="0" y="0"/>
+          <a:chExt cx="0" cy="0"/>
+        </a:xfrm>
+      </p:grpSpPr>
+      <p:sp>
+        <p:nvSpPr>
+          <p:cNvPr id="2" name="Titre 1">
+            <a:extLst>
+              <a:ext uri="{FF2B5EF4-FFF2-40B4-BE49-F238E27FC236}">
+                <a16:creationId xmlns:a16="http://schemas.microsoft.com/office/drawing/2014/main" id="{C58BF603-BA7F-9DC0-19A9-A3723A3863B8}"/>
+              </a:ext>
+            </a:extLst>
+          </p:cNvPr>
+          <p:cNvSpPr>
+            <a:spLocks noGrp="1"/>
+          </p:cNvSpPr>
+          <p:nvPr>
+            <p:ph type="title"/>
+          </p:nvPr>
+        </p:nvSpPr>
+        <p:spPr/>
+        <p:txBody>
+          <a:bodyPr/>
+          <a:lstStyle/>
+          <a:p>
+            <a:r>
+              <a:rPr lang="fr-FR" dirty="0" err="1"/>
+              <a:t>What</a:t>
+            </a:r>
+            <a:r>
+              <a:rPr lang="fr-FR" dirty="0"/>
+              <a:t> </a:t>
+            </a:r>
+            <a:r>
+              <a:rPr lang="fr-FR" dirty="0" err="1"/>
+              <a:t>is</a:t>
+            </a:r>
+            <a:r>
+              <a:rPr lang="fr-FR" dirty="0"/>
+              <a:t> </a:t>
+            </a:r>
+            <a:r>
+              <a:rPr lang="fr-FR" dirty="0" err="1"/>
+              <a:t>it</a:t>
+            </a:r>
+            <a:r>
+              <a:rPr lang="fr-FR" dirty="0"/>
+              <a:t>?</a:t>
+            </a:r>
+          </a:p>
+        </p:txBody>
+      </p:sp>
+      <p:sp>
+        <p:nvSpPr>
+          <p:cNvPr id="4" name="Espace réservé du numéro de diapositive 3">
+            <a:extLst>
+              <a:ext uri="{FF2B5EF4-FFF2-40B4-BE49-F238E27FC236}">
+                <a16:creationId xmlns:a16="http://schemas.microsoft.com/office/drawing/2014/main" id="{11D86600-22A5-1D3E-0CE5-6D5C93BDEAA2}"/>
+              </a:ext>
+            </a:extLst>
+          </p:cNvPr>
+          <p:cNvSpPr>
+            <a:spLocks noGrp="1"/>
+          </p:cNvSpPr>
+          <p:nvPr>
+            <p:ph type="sldNum" sz="quarter" idx="12"/>
+          </p:nvPr>
+        </p:nvSpPr>
+        <p:spPr/>
+        <p:txBody>
+          <a:bodyPr/>
+          <a:lstStyle/>
+          <a:p>
+            <a:fld id="{D13C05C1-FA7E-DB42-9F51-FE4437F6CA80}" type="slidenum">
+              <a:rPr lang="fr-FR" smtClean="0"/>
+              <a:t>6</a:t>
+            </a:fld>
+            <a:endParaRPr lang="fr-FR"/>
+          </a:p>
+        </p:txBody>
+      </p:sp>
+      <p:pic>
+        <p:nvPicPr>
+          <p:cNvPr id="5" name="Image 4">
+            <a:extLst>
+              <a:ext uri="{FF2B5EF4-FFF2-40B4-BE49-F238E27FC236}">
+                <a16:creationId xmlns:a16="http://schemas.microsoft.com/office/drawing/2014/main" id="{F51CEC49-0C2F-63B7-4078-CB843D68C048}"/>
+              </a:ext>
+            </a:extLst>
+          </p:cNvPr>
+          <p:cNvPicPr>
+            <a:picLocks noChangeAspect="1"/>
+          </p:cNvPicPr>
+          <p:nvPr/>
+        </p:nvPicPr>
+        <p:blipFill>
+          <a:blip r:embed="rId2"/>
+          <a:stretch>
+            <a:fillRect/>
+          </a:stretch>
+        </p:blipFill>
+        <p:spPr>
+          <a:xfrm>
+            <a:off x="6152148" y="571301"/>
+            <a:ext cx="5201652" cy="5715395"/>
+          </a:xfrm>
+          <a:prstGeom prst="rect">
+            <a:avLst/>
+          </a:prstGeom>
+        </p:spPr>
+      </p:pic>
+      <p:graphicFrame>
+        <p:nvGraphicFramePr>
+          <p:cNvPr id="8" name="Tableau 7">
+            <a:extLst>
+              <a:ext uri="{FF2B5EF4-FFF2-40B4-BE49-F238E27FC236}">
+                <a16:creationId xmlns:a16="http://schemas.microsoft.com/office/drawing/2014/main" id="{B190031B-06D7-A464-3810-4CB561807E78}"/>
+              </a:ext>
+            </a:extLst>
+          </p:cNvPr>
+          <p:cNvGraphicFramePr>
+            <a:graphicFrameLocks noGrp="1"/>
+          </p:cNvGraphicFramePr>
+          <p:nvPr>
+            <p:extLst>
+              <p:ext uri="{D42A27DB-BD31-4B8C-83A1-F6EECF244321}">
+                <p14:modId xmlns:p14="http://schemas.microsoft.com/office/powerpoint/2010/main" val="462511986"/>
+              </p:ext>
+            </p:extLst>
+          </p:nvPr>
+        </p:nvGraphicFramePr>
+        <p:xfrm>
+          <a:off x="838200" y="2151697"/>
+          <a:ext cx="4020566" cy="2554605"/>
+        </p:xfrm>
+        <a:graphic>
+          <a:graphicData uri="http://schemas.openxmlformats.org/drawingml/2006/table">
+            <a:tbl>
+              <a:tblPr>
+                <a:tableStyleId>{8EC20E35-A176-4012-BC5E-935CFFF8708E}</a:tableStyleId>
+              </a:tblPr>
+              <a:tblGrid>
+                <a:gridCol w="591566">
+                  <a:extLst>
+                    <a:ext uri="{9D8B030D-6E8A-4147-A177-3AD203B41FA5}">
+                      <a16:colId xmlns:a16="http://schemas.microsoft.com/office/drawing/2014/main" val="2342946703"/>
+                    </a:ext>
+                  </a:extLst>
+                </a:gridCol>
+                <a:gridCol w="685800">
+                  <a:extLst>
+                    <a:ext uri="{9D8B030D-6E8A-4147-A177-3AD203B41FA5}">
+                      <a16:colId xmlns:a16="http://schemas.microsoft.com/office/drawing/2014/main" val="3592238004"/>
+                    </a:ext>
+                  </a:extLst>
+                </a:gridCol>
+                <a:gridCol w="685800">
+                  <a:extLst>
+                    <a:ext uri="{9D8B030D-6E8A-4147-A177-3AD203B41FA5}">
+                      <a16:colId xmlns:a16="http://schemas.microsoft.com/office/drawing/2014/main" val="134823504"/>
+                    </a:ext>
+                  </a:extLst>
+                </a:gridCol>
+                <a:gridCol w="685800">
+                  <a:extLst>
+                    <a:ext uri="{9D8B030D-6E8A-4147-A177-3AD203B41FA5}">
+                      <a16:colId xmlns:a16="http://schemas.microsoft.com/office/drawing/2014/main" val="2481139785"/>
+                    </a:ext>
+                  </a:extLst>
+                </a:gridCol>
+                <a:gridCol w="685800">
+                  <a:extLst>
+                    <a:ext uri="{9D8B030D-6E8A-4147-A177-3AD203B41FA5}">
+                      <a16:colId xmlns:a16="http://schemas.microsoft.com/office/drawing/2014/main" val="1356182322"/>
+                    </a:ext>
+                  </a:extLst>
+                </a:gridCol>
+                <a:gridCol w="685800">
+                  <a:extLst>
+                    <a:ext uri="{9D8B030D-6E8A-4147-A177-3AD203B41FA5}">
+                      <a16:colId xmlns:a16="http://schemas.microsoft.com/office/drawing/2014/main" val="2318793102"/>
+                    </a:ext>
+                  </a:extLst>
+                </a:gridCol>
+              </a:tblGrid>
+              <a:tr h="203200">
+                <a:tc>
+                  <a:txBody>
+                    <a:bodyPr/>
+                    <a:lstStyle/>
+                    <a:p>
+                      <a:pPr algn="l" fontAlgn="b"/>
+                      <a:endParaRPr lang="fr-FR" sz="1800" b="0" i="0" u="none" strike="noStrike" dirty="0">
+                        <a:solidFill>
+                          <a:srgbClr val="000000"/>
+                        </a:solidFill>
+                        <a:effectLst/>
+                        <a:latin typeface="Aptos Narrow" panose="020B0004020202020204" pitchFamily="34" charset="0"/>
+                      </a:endParaRPr>
+                    </a:p>
+                  </a:txBody>
+                  <a:tcPr marL="9525" marR="9525" marT="9525" marB="0" anchor="b"/>
+                </a:tc>
+                <a:tc>
+                  <a:txBody>
+                    <a:bodyPr/>
+                    <a:lstStyle/>
+                    <a:p>
+                      <a:pPr algn="r" fontAlgn="b"/>
+                      <a:r>
+                        <a:rPr lang="fr-FR" sz="1800" u="none" strike="noStrike" dirty="0">
+                          <a:effectLst/>
+                        </a:rPr>
+                        <a:t>col 1</a:t>
+                      </a:r>
+                      <a:endParaRPr lang="fr-FR" sz="1800" b="0" i="0" u="none" strike="noStrike" dirty="0">
+                        <a:solidFill>
+                          <a:srgbClr val="000000"/>
+                        </a:solidFill>
+                        <a:effectLst/>
+                        <a:latin typeface="Aptos Narrow" panose="020B0004020202020204" pitchFamily="34" charset="0"/>
+                      </a:endParaRPr>
+                    </a:p>
+                  </a:txBody>
+                  <a:tcPr marL="9525" marR="9525" marT="9525" marB="0" anchor="b"/>
+                </a:tc>
+                <a:tc>
+                  <a:txBody>
+                    <a:bodyPr/>
+                    <a:lstStyle/>
+                    <a:p>
+                      <a:pPr algn="r" fontAlgn="b"/>
+                      <a:r>
+                        <a:rPr lang="fr-FR" sz="1800" u="none" strike="noStrike" dirty="0">
+                          <a:effectLst/>
+                        </a:rPr>
+                        <a:t>col 2</a:t>
+                      </a:r>
+                      <a:endParaRPr lang="fr-FR" sz="1800" b="0" i="0" u="none" strike="noStrike" dirty="0">
+                        <a:solidFill>
+                          <a:srgbClr val="000000"/>
+                        </a:solidFill>
+                        <a:effectLst/>
+                        <a:latin typeface="Aptos Narrow" panose="020B0004020202020204" pitchFamily="34" charset="0"/>
+                      </a:endParaRPr>
+                    </a:p>
+                  </a:txBody>
+                  <a:tcPr marL="9525" marR="9525" marT="9525" marB="0" anchor="b"/>
+                </a:tc>
+                <a:tc>
+                  <a:txBody>
+                    <a:bodyPr/>
+                    <a:lstStyle/>
+                    <a:p>
+                      <a:pPr algn="r" fontAlgn="b"/>
+                      <a:r>
+                        <a:rPr lang="fr-FR" sz="1800" u="none" strike="noStrike">
+                          <a:effectLst/>
+                        </a:rPr>
+                        <a:t>col 3</a:t>
+                      </a:r>
+                      <a:endParaRPr lang="fr-FR" sz="1800" b="0" i="0" u="none" strike="noStrike">
+                        <a:solidFill>
+                          <a:srgbClr val="000000"/>
+                        </a:solidFill>
+                        <a:effectLst/>
+                        <a:latin typeface="Aptos Narrow" panose="020B0004020202020204" pitchFamily="34" charset="0"/>
+                      </a:endParaRPr>
+                    </a:p>
+                  </a:txBody>
+                  <a:tcPr marL="9525" marR="9525" marT="9525" marB="0" anchor="b"/>
+                </a:tc>
+                <a:tc>
+                  <a:txBody>
+                    <a:bodyPr/>
+                    <a:lstStyle/>
+                    <a:p>
+                      <a:pPr algn="r" fontAlgn="b"/>
+                      <a:r>
+                        <a:rPr lang="fr-FR" sz="1800" u="none" strike="noStrike">
+                          <a:effectLst/>
+                        </a:rPr>
+                        <a:t>col 4</a:t>
+                      </a:r>
+                      <a:endParaRPr lang="fr-FR" sz="1800" b="0" i="0" u="none" strike="noStrike">
+                        <a:solidFill>
+                          <a:srgbClr val="000000"/>
+                        </a:solidFill>
+                        <a:effectLst/>
+                        <a:latin typeface="Aptos Narrow" panose="020B0004020202020204" pitchFamily="34" charset="0"/>
+                      </a:endParaRPr>
+                    </a:p>
+                  </a:txBody>
+                  <a:tcPr marL="9525" marR="9525" marT="9525" marB="0" anchor="b"/>
+                </a:tc>
+                <a:tc>
+                  <a:txBody>
+                    <a:bodyPr/>
+                    <a:lstStyle/>
+                    <a:p>
+                      <a:pPr algn="r" fontAlgn="b"/>
+                      <a:r>
+                        <a:rPr lang="fr-FR" sz="1800" u="none" strike="noStrike">
+                          <a:effectLst/>
+                        </a:rPr>
+                        <a:t>col 5</a:t>
+                      </a:r>
+                      <a:endParaRPr lang="fr-FR" sz="1800" b="0" i="0" u="none" strike="noStrike">
+                        <a:solidFill>
+                          <a:srgbClr val="000000"/>
+                        </a:solidFill>
+                        <a:effectLst/>
+                        <a:latin typeface="Aptos Narrow" panose="020B0004020202020204" pitchFamily="34" charset="0"/>
+                      </a:endParaRPr>
+                    </a:p>
+                  </a:txBody>
+                  <a:tcPr marL="9525" marR="9525" marT="9525" marB="0" anchor="b"/>
+                </a:tc>
+                <a:extLst>
+                  <a:ext uri="{0D108BD9-81ED-4DB2-BD59-A6C34878D82A}">
+                    <a16:rowId xmlns:a16="http://schemas.microsoft.com/office/drawing/2014/main" val="1494353805"/>
+                  </a:ext>
+                </a:extLst>
+              </a:tr>
+              <a:tr h="203200">
+                <a:tc>
+                  <a:txBody>
+                    <a:bodyPr/>
+                    <a:lstStyle/>
+                    <a:p>
+                      <a:pPr algn="l" fontAlgn="b"/>
+                      <a:r>
+                        <a:rPr lang="fr-FR" sz="1800" u="none" strike="noStrike">
+                          <a:effectLst/>
+                        </a:rPr>
+                        <a:t>row 1</a:t>
+                      </a:r>
+                      <a:endParaRPr lang="fr-FR" sz="1800" b="0" i="0" u="none" strike="noStrike">
+                        <a:solidFill>
+                          <a:srgbClr val="000000"/>
+                        </a:solidFill>
+                        <a:effectLst/>
+                        <a:latin typeface="Aptos Narrow" panose="020B0004020202020204" pitchFamily="34" charset="0"/>
+                      </a:endParaRPr>
+                    </a:p>
+                  </a:txBody>
+                  <a:tcPr marL="9525" marR="9525" marT="9525" marB="0" anchor="b"/>
+                </a:tc>
+                <a:tc>
+                  <a:txBody>
+                    <a:bodyPr/>
+                    <a:lstStyle/>
+                    <a:p>
+                      <a:pPr algn="r" fontAlgn="b"/>
+                      <a:r>
+                        <a:rPr lang="fr-FR" sz="1800" u="none" strike="noStrike" dirty="0">
+                          <a:effectLst/>
+                        </a:rPr>
+                        <a:t>-2.34</a:t>
+                      </a:r>
+                      <a:endParaRPr lang="fr-FR" sz="1800" b="0" i="0" u="none" strike="noStrike" dirty="0">
+                        <a:solidFill>
+                          <a:srgbClr val="000000"/>
+                        </a:solidFill>
+                        <a:effectLst/>
+                        <a:latin typeface="Aptos Narrow" panose="020B0004020202020204" pitchFamily="34" charset="0"/>
+                      </a:endParaRPr>
+                    </a:p>
+                  </a:txBody>
+                  <a:tcPr marL="9525" marR="9525" marT="9525" marB="0" anchor="b"/>
+                </a:tc>
+                <a:tc>
+                  <a:txBody>
+                    <a:bodyPr/>
+                    <a:lstStyle/>
+                    <a:p>
+                      <a:pPr algn="r" fontAlgn="b"/>
+                      <a:r>
+                        <a:rPr lang="fr-FR" sz="1800" u="none" strike="noStrike" dirty="0">
+                          <a:effectLst/>
+                        </a:rPr>
+                        <a:t>-2.16</a:t>
+                      </a:r>
+                      <a:endParaRPr lang="fr-FR" sz="1800" b="0" i="0" u="none" strike="noStrike" dirty="0">
+                        <a:solidFill>
+                          <a:srgbClr val="000000"/>
+                        </a:solidFill>
+                        <a:effectLst/>
+                        <a:latin typeface="Aptos Narrow" panose="020B0004020202020204" pitchFamily="34" charset="0"/>
+                      </a:endParaRPr>
+                    </a:p>
+                  </a:txBody>
+                  <a:tcPr marL="9525" marR="9525" marT="9525" marB="0" anchor="b"/>
+                </a:tc>
+                <a:tc>
+                  <a:txBody>
+                    <a:bodyPr/>
+                    <a:lstStyle/>
+                    <a:p>
+                      <a:pPr algn="r" fontAlgn="b"/>
+                      <a:r>
+                        <a:rPr lang="fr-FR" sz="1800" u="none" strike="noStrike" dirty="0">
+                          <a:effectLst/>
+                        </a:rPr>
+                        <a:t>-1.28</a:t>
+                      </a:r>
+                      <a:endParaRPr lang="fr-FR" sz="1800" b="0" i="0" u="none" strike="noStrike" dirty="0">
+                        <a:solidFill>
+                          <a:srgbClr val="000000"/>
+                        </a:solidFill>
+                        <a:effectLst/>
+                        <a:latin typeface="Aptos Narrow" panose="020B0004020202020204" pitchFamily="34" charset="0"/>
+                      </a:endParaRPr>
+                    </a:p>
+                  </a:txBody>
+                  <a:tcPr marL="9525" marR="9525" marT="9525" marB="0" anchor="b"/>
+                </a:tc>
+                <a:tc>
+                  <a:txBody>
+                    <a:bodyPr/>
+                    <a:lstStyle/>
+                    <a:p>
+                      <a:pPr algn="r" fontAlgn="b"/>
+                      <a:r>
+                        <a:rPr lang="fr-FR" sz="1800" u="none" strike="noStrike" dirty="0">
+                          <a:effectLst/>
+                        </a:rPr>
+                        <a:t>1.54</a:t>
+                      </a:r>
+                      <a:endParaRPr lang="fr-FR" sz="1800" b="0" i="0" u="none" strike="noStrike" dirty="0">
+                        <a:solidFill>
+                          <a:srgbClr val="000000"/>
+                        </a:solidFill>
+                        <a:effectLst/>
+                        <a:latin typeface="Aptos Narrow" panose="020B0004020202020204" pitchFamily="34" charset="0"/>
+                      </a:endParaRPr>
+                    </a:p>
+                  </a:txBody>
+                  <a:tcPr marL="9525" marR="9525" marT="9525" marB="0" anchor="b"/>
+                </a:tc>
+                <a:tc>
+                  <a:txBody>
+                    <a:bodyPr/>
+                    <a:lstStyle/>
+                    <a:p>
+                      <a:pPr algn="r" fontAlgn="b"/>
+                      <a:r>
+                        <a:rPr lang="fr-FR" sz="1800" u="none" strike="noStrike">
+                          <a:effectLst/>
+                        </a:rPr>
+                        <a:t>0.75</a:t>
+                      </a:r>
+                      <a:endParaRPr lang="fr-FR" sz="1800" b="0" i="0" u="none" strike="noStrike">
+                        <a:solidFill>
+                          <a:srgbClr val="000000"/>
+                        </a:solidFill>
+                        <a:effectLst/>
+                        <a:latin typeface="Aptos Narrow" panose="020B0004020202020204" pitchFamily="34" charset="0"/>
+                      </a:endParaRPr>
+                    </a:p>
+                  </a:txBody>
+                  <a:tcPr marL="9525" marR="9525" marT="9525" marB="0" anchor="b"/>
+                </a:tc>
+                <a:extLst>
+                  <a:ext uri="{0D108BD9-81ED-4DB2-BD59-A6C34878D82A}">
+                    <a16:rowId xmlns:a16="http://schemas.microsoft.com/office/drawing/2014/main" val="65730342"/>
+                  </a:ext>
+                </a:extLst>
+              </a:tr>
+              <a:tr h="203200">
+                <a:tc>
+                  <a:txBody>
+                    <a:bodyPr/>
+                    <a:lstStyle/>
+                    <a:p>
+                      <a:pPr algn="l" fontAlgn="b"/>
+                      <a:r>
+                        <a:rPr lang="fr-FR" sz="1800" u="none" strike="noStrike">
+                          <a:effectLst/>
+                        </a:rPr>
+                        <a:t>row 2</a:t>
+                      </a:r>
+                      <a:endParaRPr lang="fr-FR" sz="1800" b="0" i="0" u="none" strike="noStrike">
+                        <a:solidFill>
+                          <a:srgbClr val="000000"/>
+                        </a:solidFill>
+                        <a:effectLst/>
+                        <a:latin typeface="Aptos Narrow" panose="020B0004020202020204" pitchFamily="34" charset="0"/>
+                      </a:endParaRPr>
+                    </a:p>
+                  </a:txBody>
+                  <a:tcPr marL="9525" marR="9525" marT="9525" marB="0" anchor="b"/>
+                </a:tc>
+                <a:tc>
+                  <a:txBody>
+                    <a:bodyPr/>
+                    <a:lstStyle/>
+                    <a:p>
+                      <a:pPr algn="r" fontAlgn="b"/>
+                      <a:r>
+                        <a:rPr lang="fr-FR" sz="1800" u="none" strike="noStrike">
+                          <a:effectLst/>
+                        </a:rPr>
+                        <a:t>-1.10</a:t>
+                      </a:r>
+                      <a:endParaRPr lang="fr-FR" sz="1800" b="0" i="0" u="none" strike="noStrike">
+                        <a:solidFill>
+                          <a:srgbClr val="000000"/>
+                        </a:solidFill>
+                        <a:effectLst/>
+                        <a:latin typeface="Aptos Narrow" panose="020B0004020202020204" pitchFamily="34" charset="0"/>
+                      </a:endParaRPr>
+                    </a:p>
+                  </a:txBody>
+                  <a:tcPr marL="9525" marR="9525" marT="9525" marB="0" anchor="b"/>
+                </a:tc>
+                <a:tc>
+                  <a:txBody>
+                    <a:bodyPr/>
+                    <a:lstStyle/>
+                    <a:p>
+                      <a:pPr algn="r" fontAlgn="b"/>
+                      <a:r>
+                        <a:rPr lang="fr-FR" sz="1800" u="none" strike="noStrike" dirty="0">
+                          <a:effectLst/>
+                        </a:rPr>
+                        <a:t>-1.30</a:t>
+                      </a:r>
+                      <a:endParaRPr lang="fr-FR" sz="1800" b="0" i="0" u="none" strike="noStrike" dirty="0">
+                        <a:solidFill>
+                          <a:srgbClr val="000000"/>
+                        </a:solidFill>
+                        <a:effectLst/>
+                        <a:latin typeface="Aptos Narrow" panose="020B0004020202020204" pitchFamily="34" charset="0"/>
+                      </a:endParaRPr>
+                    </a:p>
+                  </a:txBody>
+                  <a:tcPr marL="9525" marR="9525" marT="9525" marB="0" anchor="b"/>
+                </a:tc>
+                <a:tc>
+                  <a:txBody>
+                    <a:bodyPr/>
+                    <a:lstStyle/>
+                    <a:p>
+                      <a:pPr algn="r" fontAlgn="b"/>
+                      <a:r>
+                        <a:rPr lang="fr-FR" sz="1800" u="none" strike="noStrike" dirty="0">
+                          <a:effectLst/>
+                        </a:rPr>
+                        <a:t>-0.11</a:t>
+                      </a:r>
+                      <a:endParaRPr lang="fr-FR" sz="1800" b="0" i="0" u="none" strike="noStrike" dirty="0">
+                        <a:solidFill>
+                          <a:srgbClr val="000000"/>
+                        </a:solidFill>
+                        <a:effectLst/>
+                        <a:latin typeface="Aptos Narrow" panose="020B0004020202020204" pitchFamily="34" charset="0"/>
+                      </a:endParaRPr>
+                    </a:p>
+                  </a:txBody>
+                  <a:tcPr marL="9525" marR="9525" marT="9525" marB="0" anchor="b"/>
+                </a:tc>
+                <a:tc>
+                  <a:txBody>
+                    <a:bodyPr/>
+                    <a:lstStyle/>
+                    <a:p>
+                      <a:pPr algn="r" fontAlgn="b"/>
+                      <a:r>
+                        <a:rPr lang="fr-FR" sz="1800" u="none" strike="noStrike" dirty="0">
+                          <a:effectLst/>
+                        </a:rPr>
+                        <a:t>-0.96</a:t>
+                      </a:r>
+                      <a:endParaRPr lang="fr-FR" sz="1800" b="0" i="0" u="none" strike="noStrike" dirty="0">
+                        <a:solidFill>
+                          <a:srgbClr val="000000"/>
+                        </a:solidFill>
+                        <a:effectLst/>
+                        <a:latin typeface="Aptos Narrow" panose="020B0004020202020204" pitchFamily="34" charset="0"/>
+                      </a:endParaRPr>
+                    </a:p>
+                  </a:txBody>
+                  <a:tcPr marL="9525" marR="9525" marT="9525" marB="0" anchor="b"/>
+                </a:tc>
+                <a:tc>
+                  <a:txBody>
+                    <a:bodyPr/>
+                    <a:lstStyle/>
+                    <a:p>
+                      <a:pPr algn="r" fontAlgn="b"/>
+                      <a:r>
+                        <a:rPr lang="fr-FR" sz="1800" u="none" strike="noStrike">
+                          <a:effectLst/>
+                        </a:rPr>
+                        <a:t>1.45</a:t>
+                      </a:r>
+                      <a:endParaRPr lang="fr-FR" sz="1800" b="0" i="0" u="none" strike="noStrike">
+                        <a:solidFill>
+                          <a:srgbClr val="000000"/>
+                        </a:solidFill>
+                        <a:effectLst/>
+                        <a:latin typeface="Aptos Narrow" panose="020B0004020202020204" pitchFamily="34" charset="0"/>
+                      </a:endParaRPr>
+                    </a:p>
+                  </a:txBody>
+                  <a:tcPr marL="9525" marR="9525" marT="9525" marB="0" anchor="b"/>
+                </a:tc>
+                <a:extLst>
+                  <a:ext uri="{0D108BD9-81ED-4DB2-BD59-A6C34878D82A}">
+                    <a16:rowId xmlns:a16="http://schemas.microsoft.com/office/drawing/2014/main" val="4006838636"/>
+                  </a:ext>
+                </a:extLst>
+              </a:tr>
+              <a:tr h="203200">
+                <a:tc>
+                  <a:txBody>
+                    <a:bodyPr/>
+                    <a:lstStyle/>
+                    <a:p>
+                      <a:pPr algn="l" fontAlgn="b"/>
+                      <a:r>
+                        <a:rPr lang="fr-FR" sz="1800" u="none" strike="noStrike">
+                          <a:effectLst/>
+                        </a:rPr>
+                        <a:t>row 3</a:t>
+                      </a:r>
+                      <a:endParaRPr lang="fr-FR" sz="1800" b="0" i="0" u="none" strike="noStrike">
+                        <a:solidFill>
+                          <a:srgbClr val="000000"/>
+                        </a:solidFill>
+                        <a:effectLst/>
+                        <a:latin typeface="Aptos Narrow" panose="020B0004020202020204" pitchFamily="34" charset="0"/>
+                      </a:endParaRPr>
+                    </a:p>
+                  </a:txBody>
+                  <a:tcPr marL="9525" marR="9525" marT="9525" marB="0" anchor="b"/>
+                </a:tc>
+                <a:tc>
+                  <a:txBody>
+                    <a:bodyPr/>
+                    <a:lstStyle/>
+                    <a:p>
+                      <a:pPr algn="r" fontAlgn="b"/>
+                      <a:r>
+                        <a:rPr lang="fr-FR" sz="1800" u="none" strike="noStrike" dirty="0">
+                          <a:effectLst/>
+                        </a:rPr>
+                        <a:t>-1.29</a:t>
+                      </a:r>
+                      <a:endParaRPr lang="fr-FR" sz="1800" b="0" i="0" u="none" strike="noStrike" dirty="0">
+                        <a:solidFill>
+                          <a:srgbClr val="000000"/>
+                        </a:solidFill>
+                        <a:effectLst/>
+                        <a:latin typeface="Aptos Narrow" panose="020B0004020202020204" pitchFamily="34" charset="0"/>
+                      </a:endParaRPr>
+                    </a:p>
+                  </a:txBody>
+                  <a:tcPr marL="9525" marR="9525" marT="9525" marB="0" anchor="b"/>
+                </a:tc>
+                <a:tc>
+                  <a:txBody>
+                    <a:bodyPr/>
+                    <a:lstStyle/>
+                    <a:p>
+                      <a:pPr algn="r" fontAlgn="b"/>
+                      <a:r>
+                        <a:rPr lang="fr-FR" sz="1800" u="none" strike="noStrike">
+                          <a:effectLst/>
+                        </a:rPr>
+                        <a:t>-1.47</a:t>
+                      </a:r>
+                      <a:endParaRPr lang="fr-FR" sz="1800" b="0" i="0" u="none" strike="noStrike">
+                        <a:solidFill>
+                          <a:srgbClr val="000000"/>
+                        </a:solidFill>
+                        <a:effectLst/>
+                        <a:latin typeface="Aptos Narrow" panose="020B0004020202020204" pitchFamily="34" charset="0"/>
+                      </a:endParaRPr>
+                    </a:p>
+                  </a:txBody>
+                  <a:tcPr marL="9525" marR="9525" marT="9525" marB="0" anchor="b"/>
+                </a:tc>
+                <a:tc>
+                  <a:txBody>
+                    <a:bodyPr/>
+                    <a:lstStyle/>
+                    <a:p>
+                      <a:pPr algn="r" fontAlgn="b"/>
+                      <a:r>
+                        <a:rPr lang="fr-FR" sz="1800" u="none" strike="noStrike" dirty="0">
+                          <a:effectLst/>
+                        </a:rPr>
+                        <a:t>-0.44</a:t>
+                      </a:r>
+                      <a:endParaRPr lang="fr-FR" sz="1800" b="0" i="0" u="none" strike="noStrike" dirty="0">
+                        <a:solidFill>
+                          <a:srgbClr val="000000"/>
+                        </a:solidFill>
+                        <a:effectLst/>
+                        <a:latin typeface="Aptos Narrow" panose="020B0004020202020204" pitchFamily="34" charset="0"/>
+                      </a:endParaRPr>
+                    </a:p>
+                  </a:txBody>
+                  <a:tcPr marL="9525" marR="9525" marT="9525" marB="0" anchor="b"/>
+                </a:tc>
+                <a:tc>
+                  <a:txBody>
+                    <a:bodyPr/>
+                    <a:lstStyle/>
+                    <a:p>
+                      <a:pPr algn="r" fontAlgn="b"/>
+                      <a:r>
+                        <a:rPr lang="fr-FR" sz="1800" u="none" strike="noStrike" dirty="0">
+                          <a:effectLst/>
+                        </a:rPr>
+                        <a:t>-0.02</a:t>
+                      </a:r>
+                      <a:endParaRPr lang="fr-FR" sz="1800" b="0" i="0" u="none" strike="noStrike" dirty="0">
+                        <a:solidFill>
+                          <a:srgbClr val="000000"/>
+                        </a:solidFill>
+                        <a:effectLst/>
+                        <a:latin typeface="Aptos Narrow" panose="020B0004020202020204" pitchFamily="34" charset="0"/>
+                      </a:endParaRPr>
+                    </a:p>
+                  </a:txBody>
+                  <a:tcPr marL="9525" marR="9525" marT="9525" marB="0" anchor="b"/>
+                </a:tc>
+                <a:tc>
+                  <a:txBody>
+                    <a:bodyPr/>
+                    <a:lstStyle/>
+                    <a:p>
+                      <a:pPr algn="r" fontAlgn="b"/>
+                      <a:r>
+                        <a:rPr lang="fr-FR" sz="1800" u="none" strike="noStrike">
+                          <a:effectLst/>
+                        </a:rPr>
+                        <a:t>0.65</a:t>
+                      </a:r>
+                      <a:endParaRPr lang="fr-FR" sz="1800" b="0" i="0" u="none" strike="noStrike">
+                        <a:solidFill>
+                          <a:srgbClr val="000000"/>
+                        </a:solidFill>
+                        <a:effectLst/>
+                        <a:latin typeface="Aptos Narrow" panose="020B0004020202020204" pitchFamily="34" charset="0"/>
+                      </a:endParaRPr>
+                    </a:p>
+                  </a:txBody>
+                  <a:tcPr marL="9525" marR="9525" marT="9525" marB="0" anchor="b"/>
+                </a:tc>
+                <a:extLst>
+                  <a:ext uri="{0D108BD9-81ED-4DB2-BD59-A6C34878D82A}">
+                    <a16:rowId xmlns:a16="http://schemas.microsoft.com/office/drawing/2014/main" val="3634311150"/>
+                  </a:ext>
+                </a:extLst>
+              </a:tr>
+              <a:tr h="203200">
+                <a:tc>
+                  <a:txBody>
+                    <a:bodyPr/>
+                    <a:lstStyle/>
+                    <a:p>
+                      <a:pPr algn="l" fontAlgn="b"/>
+                      <a:r>
+                        <a:rPr lang="fr-FR" sz="1800" u="none" strike="noStrike">
+                          <a:effectLst/>
+                        </a:rPr>
+                        <a:t>row 4</a:t>
+                      </a:r>
+                      <a:endParaRPr lang="fr-FR" sz="1800" b="0" i="0" u="none" strike="noStrike">
+                        <a:solidFill>
+                          <a:srgbClr val="000000"/>
+                        </a:solidFill>
+                        <a:effectLst/>
+                        <a:latin typeface="Aptos Narrow" panose="020B0004020202020204" pitchFamily="34" charset="0"/>
+                      </a:endParaRPr>
+                    </a:p>
+                  </a:txBody>
+                  <a:tcPr marL="9525" marR="9525" marT="9525" marB="0" anchor="b"/>
+                </a:tc>
+                <a:tc>
+                  <a:txBody>
+                    <a:bodyPr/>
+                    <a:lstStyle/>
+                    <a:p>
+                      <a:pPr algn="r" fontAlgn="b"/>
+                      <a:r>
+                        <a:rPr lang="fr-FR" sz="1800" u="none" strike="noStrike">
+                          <a:effectLst/>
+                        </a:rPr>
+                        <a:t>-1.18</a:t>
+                      </a:r>
+                      <a:endParaRPr lang="fr-FR" sz="1800" b="0" i="0" u="none" strike="noStrike">
+                        <a:solidFill>
+                          <a:srgbClr val="000000"/>
+                        </a:solidFill>
+                        <a:effectLst/>
+                        <a:latin typeface="Aptos Narrow" panose="020B0004020202020204" pitchFamily="34" charset="0"/>
+                      </a:endParaRPr>
+                    </a:p>
+                  </a:txBody>
+                  <a:tcPr marL="9525" marR="9525" marT="9525" marB="0" anchor="b"/>
+                </a:tc>
+                <a:tc>
+                  <a:txBody>
+                    <a:bodyPr/>
+                    <a:lstStyle/>
+                    <a:p>
+                      <a:pPr algn="r" fontAlgn="b"/>
+                      <a:r>
+                        <a:rPr lang="fr-FR" sz="1800" u="none" strike="noStrike">
+                          <a:effectLst/>
+                        </a:rPr>
+                        <a:t>-0.67</a:t>
+                      </a:r>
+                      <a:endParaRPr lang="fr-FR" sz="1800" b="0" i="0" u="none" strike="noStrike">
+                        <a:solidFill>
+                          <a:srgbClr val="000000"/>
+                        </a:solidFill>
+                        <a:effectLst/>
+                        <a:latin typeface="Aptos Narrow" panose="020B0004020202020204" pitchFamily="34" charset="0"/>
+                      </a:endParaRPr>
+                    </a:p>
+                  </a:txBody>
+                  <a:tcPr marL="9525" marR="9525" marT="9525" marB="0" anchor="b"/>
+                </a:tc>
+                <a:tc>
+                  <a:txBody>
+                    <a:bodyPr/>
+                    <a:lstStyle/>
+                    <a:p>
+                      <a:pPr algn="r" fontAlgn="b"/>
+                      <a:r>
+                        <a:rPr lang="fr-FR" sz="1800" u="none" strike="noStrike" dirty="0">
+                          <a:effectLst/>
+                        </a:rPr>
+                        <a:t>0.39</a:t>
+                      </a:r>
+                      <a:endParaRPr lang="fr-FR" sz="1800" b="0" i="0" u="none" strike="noStrike" dirty="0">
+                        <a:solidFill>
+                          <a:srgbClr val="000000"/>
+                        </a:solidFill>
+                        <a:effectLst/>
+                        <a:latin typeface="Aptos Narrow" panose="020B0004020202020204" pitchFamily="34" charset="0"/>
+                      </a:endParaRPr>
+                    </a:p>
+                  </a:txBody>
+                  <a:tcPr marL="9525" marR="9525" marT="9525" marB="0" anchor="b"/>
+                </a:tc>
+                <a:tc>
+                  <a:txBody>
+                    <a:bodyPr/>
+                    <a:lstStyle/>
+                    <a:p>
+                      <a:pPr algn="r" fontAlgn="b"/>
+                      <a:r>
+                        <a:rPr lang="fr-FR" sz="1800" u="none" strike="noStrike" dirty="0">
+                          <a:effectLst/>
+                        </a:rPr>
+                        <a:t>-0.30</a:t>
+                      </a:r>
+                      <a:endParaRPr lang="fr-FR" sz="1800" b="0" i="0" u="none" strike="noStrike" dirty="0">
+                        <a:solidFill>
+                          <a:srgbClr val="000000"/>
+                        </a:solidFill>
+                        <a:effectLst/>
+                        <a:latin typeface="Aptos Narrow" panose="020B0004020202020204" pitchFamily="34" charset="0"/>
+                      </a:endParaRPr>
+                    </a:p>
+                  </a:txBody>
+                  <a:tcPr marL="9525" marR="9525" marT="9525" marB="0" anchor="b"/>
+                </a:tc>
+                <a:tc>
+                  <a:txBody>
+                    <a:bodyPr/>
+                    <a:lstStyle/>
+                    <a:p>
+                      <a:pPr algn="r" fontAlgn="b"/>
+                      <a:r>
+                        <a:rPr lang="fr-FR" sz="1800" u="none" strike="noStrike" dirty="0">
+                          <a:effectLst/>
+                        </a:rPr>
+                        <a:t>0.70</a:t>
+                      </a:r>
+                      <a:endParaRPr lang="fr-FR" sz="1800" b="0" i="0" u="none" strike="noStrike" dirty="0">
+                        <a:solidFill>
+                          <a:srgbClr val="000000"/>
+                        </a:solidFill>
+                        <a:effectLst/>
+                        <a:latin typeface="Aptos Narrow" panose="020B0004020202020204" pitchFamily="34" charset="0"/>
+                      </a:endParaRPr>
+                    </a:p>
+                  </a:txBody>
+                  <a:tcPr marL="9525" marR="9525" marT="9525" marB="0" anchor="b"/>
+                </a:tc>
+                <a:extLst>
+                  <a:ext uri="{0D108BD9-81ED-4DB2-BD59-A6C34878D82A}">
+                    <a16:rowId xmlns:a16="http://schemas.microsoft.com/office/drawing/2014/main" val="145829497"/>
+                  </a:ext>
+                </a:extLst>
+              </a:tr>
+              <a:tr h="203200">
+                <a:tc>
+                  <a:txBody>
+                    <a:bodyPr/>
+                    <a:lstStyle/>
+                    <a:p>
+                      <a:pPr algn="l" fontAlgn="b"/>
+                      <a:r>
+                        <a:rPr lang="fr-FR" sz="1800" u="none" strike="noStrike">
+                          <a:effectLst/>
+                        </a:rPr>
+                        <a:t>row 5</a:t>
+                      </a:r>
+                      <a:endParaRPr lang="fr-FR" sz="1800" b="0" i="0" u="none" strike="noStrike">
+                        <a:solidFill>
+                          <a:srgbClr val="000000"/>
+                        </a:solidFill>
+                        <a:effectLst/>
+                        <a:latin typeface="Aptos Narrow" panose="020B0004020202020204" pitchFamily="34" charset="0"/>
+                      </a:endParaRPr>
+                    </a:p>
+                  </a:txBody>
+                  <a:tcPr marL="9525" marR="9525" marT="9525" marB="0" anchor="b"/>
+                </a:tc>
+                <a:tc>
+                  <a:txBody>
+                    <a:bodyPr/>
+                    <a:lstStyle/>
+                    <a:p>
+                      <a:pPr algn="r" fontAlgn="b"/>
+                      <a:r>
+                        <a:rPr lang="fr-FR" sz="1800" u="none" strike="noStrike">
+                          <a:effectLst/>
+                        </a:rPr>
+                        <a:t>2.22</a:t>
+                      </a:r>
+                      <a:endParaRPr lang="fr-FR" sz="1800" b="0" i="0" u="none" strike="noStrike">
+                        <a:solidFill>
+                          <a:srgbClr val="000000"/>
+                        </a:solidFill>
+                        <a:effectLst/>
+                        <a:latin typeface="Aptos Narrow" panose="020B0004020202020204" pitchFamily="34" charset="0"/>
+                      </a:endParaRPr>
+                    </a:p>
+                  </a:txBody>
+                  <a:tcPr marL="9525" marR="9525" marT="9525" marB="0" anchor="b"/>
+                </a:tc>
+                <a:tc>
+                  <a:txBody>
+                    <a:bodyPr/>
+                    <a:lstStyle/>
+                    <a:p>
+                      <a:pPr algn="r" fontAlgn="b"/>
+                      <a:r>
+                        <a:rPr lang="fr-FR" sz="1800" u="none" strike="noStrike">
+                          <a:effectLst/>
+                        </a:rPr>
+                        <a:t>1.92</a:t>
+                      </a:r>
+                      <a:endParaRPr lang="fr-FR" sz="1800" b="0" i="0" u="none" strike="noStrike">
+                        <a:solidFill>
+                          <a:srgbClr val="000000"/>
+                        </a:solidFill>
+                        <a:effectLst/>
+                        <a:latin typeface="Aptos Narrow" panose="020B0004020202020204" pitchFamily="34" charset="0"/>
+                      </a:endParaRPr>
+                    </a:p>
+                  </a:txBody>
+                  <a:tcPr marL="9525" marR="9525" marT="9525" marB="0" anchor="b"/>
+                </a:tc>
+                <a:tc>
+                  <a:txBody>
+                    <a:bodyPr/>
+                    <a:lstStyle/>
+                    <a:p>
+                      <a:pPr algn="r" fontAlgn="b"/>
+                      <a:r>
+                        <a:rPr lang="fr-FR" sz="1800" u="none" strike="noStrike" dirty="0">
+                          <a:effectLst/>
+                        </a:rPr>
+                        <a:t>1.60</a:t>
+                      </a:r>
+                      <a:endParaRPr lang="fr-FR" sz="1800" b="0" i="0" u="none" strike="noStrike" dirty="0">
+                        <a:solidFill>
+                          <a:srgbClr val="000000"/>
+                        </a:solidFill>
+                        <a:effectLst/>
+                        <a:latin typeface="Aptos Narrow" panose="020B0004020202020204" pitchFamily="34" charset="0"/>
+                      </a:endParaRPr>
+                    </a:p>
+                  </a:txBody>
+                  <a:tcPr marL="9525" marR="9525" marT="9525" marB="0" anchor="b"/>
+                </a:tc>
+                <a:tc>
+                  <a:txBody>
+                    <a:bodyPr/>
+                    <a:lstStyle/>
+                    <a:p>
+                      <a:pPr algn="r" fontAlgn="b"/>
+                      <a:r>
+                        <a:rPr lang="fr-FR" sz="1800" u="none" strike="noStrike" dirty="0">
+                          <a:effectLst/>
+                        </a:rPr>
+                        <a:t>-1.90</a:t>
+                      </a:r>
+                      <a:endParaRPr lang="fr-FR" sz="1800" b="0" i="0" u="none" strike="noStrike" dirty="0">
+                        <a:solidFill>
+                          <a:srgbClr val="000000"/>
+                        </a:solidFill>
+                        <a:effectLst/>
+                        <a:latin typeface="Aptos Narrow" panose="020B0004020202020204" pitchFamily="34" charset="0"/>
+                      </a:endParaRPr>
+                    </a:p>
+                  </a:txBody>
+                  <a:tcPr marL="9525" marR="9525" marT="9525" marB="0" anchor="b"/>
+                </a:tc>
+                <a:tc>
+                  <a:txBody>
+                    <a:bodyPr/>
+                    <a:lstStyle/>
+                    <a:p>
+                      <a:pPr algn="r" fontAlgn="b"/>
+                      <a:r>
+                        <a:rPr lang="fr-FR" sz="1800" u="none" strike="noStrike" dirty="0">
+                          <a:effectLst/>
+                        </a:rPr>
+                        <a:t>1.34</a:t>
+                      </a:r>
+                      <a:endParaRPr lang="fr-FR" sz="1800" b="0" i="0" u="none" strike="noStrike" dirty="0">
+                        <a:solidFill>
+                          <a:srgbClr val="000000"/>
+                        </a:solidFill>
+                        <a:effectLst/>
+                        <a:latin typeface="Aptos Narrow" panose="020B0004020202020204" pitchFamily="34" charset="0"/>
+                      </a:endParaRPr>
+                    </a:p>
+                  </a:txBody>
+                  <a:tcPr marL="9525" marR="9525" marT="9525" marB="0" anchor="b"/>
+                </a:tc>
+                <a:extLst>
+                  <a:ext uri="{0D108BD9-81ED-4DB2-BD59-A6C34878D82A}">
+                    <a16:rowId xmlns:a16="http://schemas.microsoft.com/office/drawing/2014/main" val="2800517638"/>
+                  </a:ext>
+                </a:extLst>
+              </a:tr>
+              <a:tr h="203200">
+                <a:tc>
+                  <a:txBody>
+                    <a:bodyPr/>
+                    <a:lstStyle/>
+                    <a:p>
+                      <a:pPr algn="l" fontAlgn="b"/>
+                      <a:r>
+                        <a:rPr lang="fr-FR" sz="1800" u="none" strike="noStrike">
+                          <a:effectLst/>
+                        </a:rPr>
+                        <a:t>row 6</a:t>
+                      </a:r>
+                      <a:endParaRPr lang="fr-FR" sz="1800" b="0" i="0" u="none" strike="noStrike">
+                        <a:solidFill>
+                          <a:srgbClr val="000000"/>
+                        </a:solidFill>
+                        <a:effectLst/>
+                        <a:latin typeface="Aptos Narrow" panose="020B0004020202020204" pitchFamily="34" charset="0"/>
+                      </a:endParaRPr>
+                    </a:p>
+                  </a:txBody>
+                  <a:tcPr marL="9525" marR="9525" marT="9525" marB="0" anchor="b"/>
+                </a:tc>
+                <a:tc>
+                  <a:txBody>
+                    <a:bodyPr/>
+                    <a:lstStyle/>
+                    <a:p>
+                      <a:pPr algn="r" fontAlgn="b"/>
+                      <a:r>
+                        <a:rPr lang="fr-FR" sz="1800" u="none" strike="noStrike">
+                          <a:effectLst/>
+                        </a:rPr>
+                        <a:t>2.53</a:t>
+                      </a:r>
+                      <a:endParaRPr lang="fr-FR" sz="1800" b="0" i="0" u="none" strike="noStrike">
+                        <a:solidFill>
+                          <a:srgbClr val="000000"/>
+                        </a:solidFill>
+                        <a:effectLst/>
+                        <a:latin typeface="Aptos Narrow" panose="020B0004020202020204" pitchFamily="34" charset="0"/>
+                      </a:endParaRPr>
+                    </a:p>
+                  </a:txBody>
+                  <a:tcPr marL="9525" marR="9525" marT="9525" marB="0" anchor="b"/>
+                </a:tc>
+                <a:tc>
+                  <a:txBody>
+                    <a:bodyPr/>
+                    <a:lstStyle/>
+                    <a:p>
+                      <a:pPr algn="r" fontAlgn="b"/>
+                      <a:r>
+                        <a:rPr lang="fr-FR" sz="1800" u="none" strike="noStrike">
+                          <a:effectLst/>
+                        </a:rPr>
+                        <a:t>2.75</a:t>
+                      </a:r>
+                      <a:endParaRPr lang="fr-FR" sz="1800" b="0" i="0" u="none" strike="noStrike">
+                        <a:solidFill>
+                          <a:srgbClr val="000000"/>
+                        </a:solidFill>
+                        <a:effectLst/>
+                        <a:latin typeface="Aptos Narrow" panose="020B0004020202020204" pitchFamily="34" charset="0"/>
+                      </a:endParaRPr>
+                    </a:p>
+                  </a:txBody>
+                  <a:tcPr marL="9525" marR="9525" marT="9525" marB="0" anchor="b"/>
+                </a:tc>
+                <a:tc>
+                  <a:txBody>
+                    <a:bodyPr/>
+                    <a:lstStyle/>
+                    <a:p>
+                      <a:pPr algn="r" fontAlgn="b"/>
+                      <a:r>
+                        <a:rPr lang="fr-FR" sz="1800" u="none" strike="noStrike">
+                          <a:effectLst/>
+                        </a:rPr>
+                        <a:t>0.75</a:t>
+                      </a:r>
+                      <a:endParaRPr lang="fr-FR" sz="1800" b="0" i="0" u="none" strike="noStrike">
+                        <a:solidFill>
+                          <a:srgbClr val="000000"/>
+                        </a:solidFill>
+                        <a:effectLst/>
+                        <a:latin typeface="Aptos Narrow" panose="020B0004020202020204" pitchFamily="34" charset="0"/>
+                      </a:endParaRPr>
+                    </a:p>
+                  </a:txBody>
+                  <a:tcPr marL="9525" marR="9525" marT="9525" marB="0" anchor="b"/>
+                </a:tc>
+                <a:tc>
+                  <a:txBody>
+                    <a:bodyPr/>
+                    <a:lstStyle/>
+                    <a:p>
+                      <a:pPr algn="r" fontAlgn="b"/>
+                      <a:r>
+                        <a:rPr lang="fr-FR" sz="1800" u="none" strike="noStrike" dirty="0">
+                          <a:effectLst/>
+                        </a:rPr>
+                        <a:t>0.86</a:t>
+                      </a:r>
+                      <a:endParaRPr lang="fr-FR" sz="1800" b="0" i="0" u="none" strike="noStrike" dirty="0">
+                        <a:solidFill>
+                          <a:srgbClr val="000000"/>
+                        </a:solidFill>
+                        <a:effectLst/>
+                        <a:latin typeface="Aptos Narrow" panose="020B0004020202020204" pitchFamily="34" charset="0"/>
+                      </a:endParaRPr>
+                    </a:p>
+                  </a:txBody>
+                  <a:tcPr marL="9525" marR="9525" marT="9525" marB="0" anchor="b"/>
+                </a:tc>
+                <a:tc>
+                  <a:txBody>
+                    <a:bodyPr/>
+                    <a:lstStyle/>
+                    <a:p>
+                      <a:pPr algn="r" fontAlgn="b"/>
+                      <a:r>
+                        <a:rPr lang="fr-FR" sz="1800" u="none" strike="noStrike" dirty="0">
+                          <a:effectLst/>
+                        </a:rPr>
+                        <a:t>0.52</a:t>
+                      </a:r>
+                      <a:endParaRPr lang="fr-FR" sz="1800" b="0" i="0" u="none" strike="noStrike" dirty="0">
+                        <a:solidFill>
+                          <a:srgbClr val="000000"/>
+                        </a:solidFill>
+                        <a:effectLst/>
+                        <a:latin typeface="Aptos Narrow" panose="020B0004020202020204" pitchFamily="34" charset="0"/>
+                      </a:endParaRPr>
+                    </a:p>
+                  </a:txBody>
+                  <a:tcPr marL="9525" marR="9525" marT="9525" marB="0" anchor="b"/>
+                </a:tc>
+                <a:extLst>
+                  <a:ext uri="{0D108BD9-81ED-4DB2-BD59-A6C34878D82A}">
+                    <a16:rowId xmlns:a16="http://schemas.microsoft.com/office/drawing/2014/main" val="2601306499"/>
+                  </a:ext>
+                </a:extLst>
+              </a:tr>
+              <a:tr h="203200">
+                <a:tc>
+                  <a:txBody>
+                    <a:bodyPr/>
+                    <a:lstStyle/>
+                    <a:p>
+                      <a:pPr algn="l" fontAlgn="b"/>
+                      <a:r>
+                        <a:rPr lang="fr-FR" sz="1800" u="none" strike="noStrike">
+                          <a:effectLst/>
+                        </a:rPr>
+                        <a:t>row 7</a:t>
+                      </a:r>
+                      <a:endParaRPr lang="fr-FR" sz="1800" b="0" i="0" u="none" strike="noStrike">
+                        <a:solidFill>
+                          <a:srgbClr val="000000"/>
+                        </a:solidFill>
+                        <a:effectLst/>
+                        <a:latin typeface="Aptos Narrow" panose="020B0004020202020204" pitchFamily="34" charset="0"/>
+                      </a:endParaRPr>
+                    </a:p>
+                  </a:txBody>
+                  <a:tcPr marL="9525" marR="9525" marT="9525" marB="0" anchor="b"/>
+                </a:tc>
+                <a:tc>
+                  <a:txBody>
+                    <a:bodyPr/>
+                    <a:lstStyle/>
+                    <a:p>
+                      <a:pPr algn="r" fontAlgn="b"/>
+                      <a:r>
+                        <a:rPr lang="fr-FR" sz="1800" u="none" strike="noStrike">
+                          <a:effectLst/>
+                        </a:rPr>
+                        <a:t>0.78</a:t>
+                      </a:r>
+                      <a:endParaRPr lang="fr-FR" sz="1800" b="0" i="0" u="none" strike="noStrike">
+                        <a:solidFill>
+                          <a:srgbClr val="000000"/>
+                        </a:solidFill>
+                        <a:effectLst/>
+                        <a:latin typeface="Aptos Narrow" panose="020B0004020202020204" pitchFamily="34" charset="0"/>
+                      </a:endParaRPr>
+                    </a:p>
+                  </a:txBody>
+                  <a:tcPr marL="9525" marR="9525" marT="9525" marB="0" anchor="b"/>
+                </a:tc>
+                <a:tc>
+                  <a:txBody>
+                    <a:bodyPr/>
+                    <a:lstStyle/>
+                    <a:p>
+                      <a:pPr algn="r" fontAlgn="b"/>
+                      <a:r>
+                        <a:rPr lang="fr-FR" sz="1800" u="none" strike="noStrike">
+                          <a:effectLst/>
+                        </a:rPr>
+                        <a:t>0.65</a:t>
+                      </a:r>
+                      <a:endParaRPr lang="fr-FR" sz="1800" b="0" i="0" u="none" strike="noStrike">
+                        <a:solidFill>
+                          <a:srgbClr val="000000"/>
+                        </a:solidFill>
+                        <a:effectLst/>
+                        <a:latin typeface="Aptos Narrow" panose="020B0004020202020204" pitchFamily="34" charset="0"/>
+                      </a:endParaRPr>
+                    </a:p>
+                  </a:txBody>
+                  <a:tcPr marL="9525" marR="9525" marT="9525" marB="0" anchor="b"/>
+                </a:tc>
+                <a:tc>
+                  <a:txBody>
+                    <a:bodyPr/>
+                    <a:lstStyle/>
+                    <a:p>
+                      <a:pPr algn="r" fontAlgn="b"/>
+                      <a:r>
+                        <a:rPr lang="fr-FR" sz="1800" u="none" strike="noStrike">
+                          <a:effectLst/>
+                        </a:rPr>
+                        <a:t>-0.41</a:t>
+                      </a:r>
+                      <a:endParaRPr lang="fr-FR" sz="1800" b="0" i="0" u="none" strike="noStrike">
+                        <a:solidFill>
+                          <a:srgbClr val="000000"/>
+                        </a:solidFill>
+                        <a:effectLst/>
+                        <a:latin typeface="Aptos Narrow" panose="020B0004020202020204" pitchFamily="34" charset="0"/>
+                      </a:endParaRPr>
+                    </a:p>
+                  </a:txBody>
+                  <a:tcPr marL="9525" marR="9525" marT="9525" marB="0" anchor="b"/>
+                </a:tc>
+                <a:tc>
+                  <a:txBody>
+                    <a:bodyPr/>
+                    <a:lstStyle/>
+                    <a:p>
+                      <a:pPr algn="r" fontAlgn="b"/>
+                      <a:r>
+                        <a:rPr lang="fr-FR" sz="1800" u="none" strike="noStrike" dirty="0">
+                          <a:effectLst/>
+                        </a:rPr>
+                        <a:t>-1.03</a:t>
+                      </a:r>
+                      <a:endParaRPr lang="fr-FR" sz="1800" b="0" i="0" u="none" strike="noStrike" dirty="0">
+                        <a:solidFill>
+                          <a:srgbClr val="000000"/>
+                        </a:solidFill>
+                        <a:effectLst/>
+                        <a:latin typeface="Aptos Narrow" panose="020B0004020202020204" pitchFamily="34" charset="0"/>
+                      </a:endParaRPr>
+                    </a:p>
+                  </a:txBody>
+                  <a:tcPr marL="9525" marR="9525" marT="9525" marB="0" anchor="b"/>
+                </a:tc>
+                <a:tc>
+                  <a:txBody>
+                    <a:bodyPr/>
+                    <a:lstStyle/>
+                    <a:p>
+                      <a:pPr algn="r" fontAlgn="b"/>
+                      <a:r>
+                        <a:rPr lang="fr-FR" sz="1800" u="none" strike="noStrike" dirty="0">
+                          <a:effectLst/>
+                        </a:rPr>
+                        <a:t>1.38</a:t>
+                      </a:r>
+                      <a:endParaRPr lang="fr-FR" sz="1800" b="0" i="0" u="none" strike="noStrike" dirty="0">
+                        <a:solidFill>
+                          <a:srgbClr val="000000"/>
+                        </a:solidFill>
+                        <a:effectLst/>
+                        <a:latin typeface="Aptos Narrow" panose="020B0004020202020204" pitchFamily="34" charset="0"/>
+                      </a:endParaRPr>
+                    </a:p>
+                  </a:txBody>
+                  <a:tcPr marL="9525" marR="9525" marT="9525" marB="0" anchor="b"/>
+                </a:tc>
+                <a:extLst>
+                  <a:ext uri="{0D108BD9-81ED-4DB2-BD59-A6C34878D82A}">
+                    <a16:rowId xmlns:a16="http://schemas.microsoft.com/office/drawing/2014/main" val="3723817899"/>
+                  </a:ext>
+                </a:extLst>
+              </a:tr>
+              <a:tr h="203200">
+                <a:tc>
+                  <a:txBody>
+                    <a:bodyPr/>
+                    <a:lstStyle/>
+                    <a:p>
+                      <a:pPr algn="l" fontAlgn="b"/>
+                      <a:r>
+                        <a:rPr lang="fr-FR" sz="1800" u="none" strike="noStrike" dirty="0" err="1">
+                          <a:effectLst/>
+                        </a:rPr>
+                        <a:t>row</a:t>
+                      </a:r>
+                      <a:r>
+                        <a:rPr lang="fr-FR" sz="1800" u="none" strike="noStrike" dirty="0">
+                          <a:effectLst/>
+                        </a:rPr>
+                        <a:t> 8</a:t>
+                      </a:r>
+                      <a:endParaRPr lang="fr-FR" sz="1800" b="0" i="0" u="none" strike="noStrike" dirty="0">
+                        <a:solidFill>
+                          <a:srgbClr val="000000"/>
+                        </a:solidFill>
+                        <a:effectLst/>
+                        <a:latin typeface="Aptos Narrow" panose="020B0004020202020204" pitchFamily="34" charset="0"/>
+                      </a:endParaRPr>
+                    </a:p>
+                  </a:txBody>
+                  <a:tcPr marL="9525" marR="9525" marT="9525" marB="0" anchor="b"/>
+                </a:tc>
+                <a:tc>
+                  <a:txBody>
+                    <a:bodyPr/>
+                    <a:lstStyle/>
+                    <a:p>
+                      <a:pPr algn="r" fontAlgn="b"/>
+                      <a:r>
+                        <a:rPr lang="fr-FR" sz="1800" u="none" strike="noStrike">
+                          <a:effectLst/>
+                        </a:rPr>
+                        <a:t>0.84</a:t>
+                      </a:r>
+                      <a:endParaRPr lang="fr-FR" sz="1800" b="0" i="0" u="none" strike="noStrike">
+                        <a:solidFill>
+                          <a:srgbClr val="000000"/>
+                        </a:solidFill>
+                        <a:effectLst/>
+                        <a:latin typeface="Aptos Narrow" panose="020B0004020202020204" pitchFamily="34" charset="0"/>
+                      </a:endParaRPr>
+                    </a:p>
+                  </a:txBody>
+                  <a:tcPr marL="9525" marR="9525" marT="9525" marB="0" anchor="b"/>
+                </a:tc>
+                <a:tc>
+                  <a:txBody>
+                    <a:bodyPr/>
+                    <a:lstStyle/>
+                    <a:p>
+                      <a:pPr algn="r" fontAlgn="b"/>
+                      <a:r>
+                        <a:rPr lang="fr-FR" sz="1800" u="none" strike="noStrike">
+                          <a:effectLst/>
+                        </a:rPr>
+                        <a:t>0.83</a:t>
+                      </a:r>
+                      <a:endParaRPr lang="fr-FR" sz="1800" b="0" i="0" u="none" strike="noStrike">
+                        <a:solidFill>
+                          <a:srgbClr val="000000"/>
+                        </a:solidFill>
+                        <a:effectLst/>
+                        <a:latin typeface="Aptos Narrow" panose="020B0004020202020204" pitchFamily="34" charset="0"/>
+                      </a:endParaRPr>
+                    </a:p>
+                  </a:txBody>
+                  <a:tcPr marL="9525" marR="9525" marT="9525" marB="0" anchor="b"/>
+                </a:tc>
+                <a:tc>
+                  <a:txBody>
+                    <a:bodyPr/>
+                    <a:lstStyle/>
+                    <a:p>
+                      <a:pPr algn="r" fontAlgn="b"/>
+                      <a:r>
+                        <a:rPr lang="fr-FR" sz="1800" u="none" strike="noStrike">
+                          <a:effectLst/>
+                        </a:rPr>
+                        <a:t>0.00</a:t>
+                      </a:r>
+                      <a:endParaRPr lang="fr-FR" sz="1800" b="0" i="0" u="none" strike="noStrike">
+                        <a:solidFill>
+                          <a:srgbClr val="000000"/>
+                        </a:solidFill>
+                        <a:effectLst/>
+                        <a:latin typeface="Aptos Narrow" panose="020B0004020202020204" pitchFamily="34" charset="0"/>
+                      </a:endParaRPr>
+                    </a:p>
+                  </a:txBody>
+                  <a:tcPr marL="9525" marR="9525" marT="9525" marB="0" anchor="b"/>
+                </a:tc>
+                <a:tc>
+                  <a:txBody>
+                    <a:bodyPr/>
+                    <a:lstStyle/>
+                    <a:p>
+                      <a:pPr algn="r" fontAlgn="b"/>
+                      <a:r>
+                        <a:rPr lang="fr-FR" sz="1800" u="none" strike="noStrike">
+                          <a:effectLst/>
+                        </a:rPr>
+                        <a:t>0.56</a:t>
+                      </a:r>
+                      <a:endParaRPr lang="fr-FR" sz="1800" b="0" i="0" u="none" strike="noStrike">
+                        <a:solidFill>
+                          <a:srgbClr val="000000"/>
+                        </a:solidFill>
+                        <a:effectLst/>
+                        <a:latin typeface="Aptos Narrow" panose="020B0004020202020204" pitchFamily="34" charset="0"/>
+                      </a:endParaRPr>
+                    </a:p>
+                  </a:txBody>
+                  <a:tcPr marL="9525" marR="9525" marT="9525" marB="0" anchor="b"/>
+                </a:tc>
+                <a:tc>
+                  <a:txBody>
+                    <a:bodyPr/>
+                    <a:lstStyle/>
+                    <a:p>
+                      <a:pPr algn="r" fontAlgn="b"/>
+                      <a:r>
+                        <a:rPr lang="fr-FR" sz="1800" u="none" strike="noStrike" dirty="0">
+                          <a:effectLst/>
+                        </a:rPr>
+                        <a:t>-1.39</a:t>
+                      </a:r>
+                      <a:endParaRPr lang="fr-FR" sz="1800" b="0" i="0" u="none" strike="noStrike" dirty="0">
+                        <a:solidFill>
+                          <a:srgbClr val="000000"/>
+                        </a:solidFill>
+                        <a:effectLst/>
+                        <a:latin typeface="Aptos Narrow" panose="020B0004020202020204" pitchFamily="34" charset="0"/>
+                      </a:endParaRPr>
+                    </a:p>
+                  </a:txBody>
+                  <a:tcPr marL="9525" marR="9525" marT="9525" marB="0" anchor="b"/>
+                </a:tc>
+                <a:extLst>
+                  <a:ext uri="{0D108BD9-81ED-4DB2-BD59-A6C34878D82A}">
+                    <a16:rowId xmlns:a16="http://schemas.microsoft.com/office/drawing/2014/main" val="3164219867"/>
+                  </a:ext>
+                </a:extLst>
+              </a:tr>
+            </a:tbl>
+          </a:graphicData>
+        </a:graphic>
+      </p:graphicFrame>
+      <p:sp>
+        <p:nvSpPr>
+          <p:cNvPr id="9" name="Flèche vers la droite 8">
+            <a:extLst>
+              <a:ext uri="{FF2B5EF4-FFF2-40B4-BE49-F238E27FC236}">
+                <a16:creationId xmlns:a16="http://schemas.microsoft.com/office/drawing/2014/main" id="{C95E671C-D553-F9B3-C309-D2BCE261BD19}"/>
+              </a:ext>
+            </a:extLst>
+          </p:cNvPr>
+          <p:cNvSpPr/>
+          <p:nvPr/>
+        </p:nvSpPr>
+        <p:spPr>
+          <a:xfrm>
+            <a:off x="5216893" y="3272589"/>
+            <a:ext cx="1174282" cy="288758"/>
+          </a:xfrm>
+          <a:prstGeom prst="rightArrow">
+            <a:avLst/>
+          </a:prstGeom>
+          <a:pattFill prst="pct70">
+            <a:fgClr>
+              <a:schemeClr val="accent5"/>
+            </a:fgClr>
+            <a:bgClr>
+              <a:schemeClr val="bg1"/>
+            </a:bgClr>
+          </a:pattFill>
+        </p:spPr>
+        <p:style>
+          <a:lnRef idx="3">
+            <a:schemeClr val="lt1"/>
+          </a:lnRef>
+          <a:fillRef idx="1">
+            <a:schemeClr val="accent5"/>
+          </a:fillRef>
+          <a:effectRef idx="1">
+            <a:schemeClr val="accent5"/>
+          </a:effectRef>
+          <a:fontRef idx="minor">
+            <a:schemeClr val="lt1"/>
+          </a:fontRef>
+        </p:style>
+        <p:txBody>
+          <a:bodyPr rtlCol="0" anchor="ctr"/>
+          <a:lstStyle/>
+          <a:p>
+            <a:pPr algn="ctr"/>
+            <a:endParaRPr lang="fr-FR"/>
+          </a:p>
+        </p:txBody>
+      </p:sp>
+    </p:spTree>
+    <p:extLst>
+      <p:ext uri="{BB962C8B-B14F-4D97-AF65-F5344CB8AC3E}">
+        <p14:creationId xmlns:p14="http://schemas.microsoft.com/office/powerpoint/2010/main" val="1316584212"/>
+      </p:ext>
+    </p:extLst>
+  </p:cSld>
+  <p:clrMapOvr>
+    <a:masterClrMapping/>
+  </p:clrMapOvr>
+</p:sld>
+</file>
+
+<file path=ppt/slides/slide8.xml><?xml version="1.0" encoding="utf-8"?>
+<p:sld xmlns:a="http://schemas.openxmlformats.org/drawingml/2006/main" xmlns:r="http://schemas.openxmlformats.org/officeDocument/2006/relationships" xmlns:p="http://schemas.openxmlformats.org/presentationml/2006/main">
+  <p:cSld>
+    <p:spTree>
+      <p:nvGrpSpPr>
+        <p:cNvPr id="1" name=""/>
+        <p:cNvGrpSpPr/>
+        <p:nvPr/>
+      </p:nvGrpSpPr>
+      <p:grpSpPr>
+        <a:xfrm>
+          <a:off x="0" y="0"/>
+          <a:ext cx="0" cy="0"/>
+          <a:chOff x="0" y="0"/>
+          <a:chExt cx="0" cy="0"/>
+        </a:xfrm>
+      </p:grpSpPr>
+      <p:sp>
+        <p:nvSpPr>
+          <p:cNvPr id="5" name="Titre 4">
+            <a:extLst>
+              <a:ext uri="{FF2B5EF4-FFF2-40B4-BE49-F238E27FC236}">
+                <a16:creationId xmlns:a16="http://schemas.microsoft.com/office/drawing/2014/main" id="{09567641-9771-11B2-5652-8895C0F49784}"/>
+              </a:ext>
+            </a:extLst>
+          </p:cNvPr>
+          <p:cNvSpPr>
+            <a:spLocks noGrp="1"/>
+          </p:cNvSpPr>
+          <p:nvPr>
+            <p:ph type="title"/>
+          </p:nvPr>
+        </p:nvSpPr>
+        <p:spPr/>
+        <p:txBody>
+          <a:bodyPr/>
+          <a:lstStyle/>
+          <a:p>
+            <a:r>
+              <a:rPr lang="fr-FR" dirty="0"/>
+              <a:t>Composition</a:t>
+            </a:r>
+          </a:p>
+        </p:txBody>
+      </p:sp>
+      <p:sp>
+        <p:nvSpPr>
+          <p:cNvPr id="4" name="Espace réservé du numéro de diapositive 3">
+            <a:extLst>
+              <a:ext uri="{FF2B5EF4-FFF2-40B4-BE49-F238E27FC236}">
+                <a16:creationId xmlns:a16="http://schemas.microsoft.com/office/drawing/2014/main" id="{947A7FEF-16B0-0267-BB20-E2603FAC8614}"/>
+              </a:ext>
+            </a:extLst>
+          </p:cNvPr>
+          <p:cNvSpPr>
+            <a:spLocks noGrp="1"/>
+          </p:cNvSpPr>
+          <p:nvPr>
+            <p:ph type="sldNum" sz="quarter" idx="12"/>
+          </p:nvPr>
+        </p:nvSpPr>
+        <p:spPr/>
+        <p:txBody>
+          <a:bodyPr/>
+          <a:lstStyle/>
+          <a:p>
+            <a:fld id="{D13C05C1-FA7E-DB42-9F51-FE4437F6CA80}" type="slidenum">
+              <a:rPr lang="fr-FR" smtClean="0"/>
+              <a:t>7</a:t>
+            </a:fld>
+            <a:endParaRPr lang="fr-FR"/>
+          </a:p>
+        </p:txBody>
+      </p:sp>
+      <p:pic>
+        <p:nvPicPr>
+          <p:cNvPr id="7" name="Picture 1" descr="99_slides_with_code_files/figure-pptx/pheatmap%20simulation-1.png">
+            <a:extLst>
+              <a:ext uri="{FF2B5EF4-FFF2-40B4-BE49-F238E27FC236}">
+                <a16:creationId xmlns:a16="http://schemas.microsoft.com/office/drawing/2014/main" id="{BC983BD0-4866-6583-5EE1-31440E486BE0}"/>
+              </a:ext>
+            </a:extLst>
+          </p:cNvPr>
+          <p:cNvPicPr>
+            <a:picLocks noGrp="1" noChangeAspect="1"/>
+          </p:cNvPicPr>
+          <p:nvPr/>
+        </p:nvPicPr>
+        <p:blipFill>
+          <a:blip r:embed="rId2"/>
+          <a:srcRect l="34168" t="16435" r="35667" b="16447"/>
+          <a:stretch>
+            <a:fillRect/>
+          </a:stretch>
+        </p:blipFill>
+        <p:spPr bwMode="auto">
+          <a:xfrm>
+            <a:off x="3537283" y="1690688"/>
+            <a:ext cx="4109988" cy="4572362"/>
+          </a:xfrm>
+          <a:prstGeom prst="rect">
+            <a:avLst/>
+          </a:prstGeom>
+          <a:noFill/>
+          <a:ln w="9525">
+            <a:noFill/>
+            <a:headEnd/>
+            <a:tailEnd/>
+          </a:ln>
+        </p:spPr>
+      </p:pic>
+      <p:sp>
+        <p:nvSpPr>
+          <p:cNvPr id="8" name="Rectangle 7">
+            <a:extLst>
+              <a:ext uri="{FF2B5EF4-FFF2-40B4-BE49-F238E27FC236}">
+                <a16:creationId xmlns:a16="http://schemas.microsoft.com/office/drawing/2014/main" id="{38F3EA5C-94B7-95BE-43B3-CF6C52F3CA5D}"/>
+              </a:ext>
+            </a:extLst>
+          </p:cNvPr>
+          <p:cNvSpPr/>
+          <p:nvPr/>
+        </p:nvSpPr>
+        <p:spPr>
+          <a:xfrm>
+            <a:off x="4764505" y="1690688"/>
+            <a:ext cx="1713297" cy="1091013"/>
+          </a:xfrm>
+          <a:prstGeom prst="rect">
+            <a:avLst/>
+          </a:prstGeom>
+          <a:noFill/>
+        </p:spPr>
+        <p:style>
+          <a:lnRef idx="2">
+            <a:schemeClr val="accent1"/>
+          </a:lnRef>
+          <a:fillRef idx="1">
+            <a:schemeClr val="lt1"/>
+          </a:fillRef>
+          <a:effectRef idx="0">
+            <a:schemeClr val="accent1"/>
+          </a:effectRef>
+          <a:fontRef idx="minor">
+            <a:schemeClr val="dk1"/>
+          </a:fontRef>
+        </p:style>
+        <p:txBody>
+          <a:bodyPr rtlCol="0" anchor="ctr"/>
+          <a:lstStyle/>
+          <a:p>
+            <a:pPr algn="ctr"/>
+            <a:endParaRPr lang="fr-FR"/>
+          </a:p>
+        </p:txBody>
+      </p:sp>
+      <p:sp>
+        <p:nvSpPr>
+          <p:cNvPr id="9" name="Légende à une bordure 1 8">
+            <a:extLst>
+              <a:ext uri="{FF2B5EF4-FFF2-40B4-BE49-F238E27FC236}">
+                <a16:creationId xmlns:a16="http://schemas.microsoft.com/office/drawing/2014/main" id="{929BD7F1-C3C4-FF4B-2829-B5BD8CC7319A}"/>
+              </a:ext>
+            </a:extLst>
+          </p:cNvPr>
+          <p:cNvSpPr/>
+          <p:nvPr/>
+        </p:nvSpPr>
+        <p:spPr>
+          <a:xfrm>
+            <a:off x="6410425" y="365125"/>
+            <a:ext cx="1992430" cy="1155667"/>
+          </a:xfrm>
+          <a:prstGeom prst="accentCallout1">
+            <a:avLst/>
+          </a:prstGeom>
+        </p:spPr>
+        <p:style>
+          <a:lnRef idx="2">
+            <a:schemeClr val="accent1">
+              <a:shade val="15000"/>
+            </a:schemeClr>
+          </a:lnRef>
+          <a:fillRef idx="1">
+            <a:schemeClr val="accent1"/>
+          </a:fillRef>
+          <a:effectRef idx="0">
+            <a:schemeClr val="accent1"/>
+          </a:effectRef>
+          <a:fontRef idx="minor">
+            <a:schemeClr val="lt1"/>
+          </a:fontRef>
+        </p:style>
+        <p:txBody>
+          <a:bodyPr rtlCol="0" anchor="ctr"/>
+          <a:lstStyle/>
+          <a:p>
+            <a:pPr algn="ctr"/>
+            <a:r>
+              <a:rPr lang="fr-FR" dirty="0" err="1"/>
+              <a:t>Dendrogram</a:t>
+            </a:r>
+            <a:r>
+              <a:rPr lang="fr-FR" dirty="0"/>
+              <a:t> of the </a:t>
+            </a:r>
+            <a:r>
+              <a:rPr lang="fr-FR" dirty="0" err="1"/>
+              <a:t>columns</a:t>
+            </a:r>
+            <a:endParaRPr lang="fr-FR" dirty="0"/>
+          </a:p>
+        </p:txBody>
+      </p:sp>
+      <p:sp>
+        <p:nvSpPr>
+          <p:cNvPr id="10" name="Rectangle 9">
+            <a:extLst>
+              <a:ext uri="{FF2B5EF4-FFF2-40B4-BE49-F238E27FC236}">
+                <a16:creationId xmlns:a16="http://schemas.microsoft.com/office/drawing/2014/main" id="{258E4BC1-DB43-E881-7987-EA2C55968AAA}"/>
+              </a:ext>
+            </a:extLst>
+          </p:cNvPr>
+          <p:cNvSpPr/>
+          <p:nvPr/>
+        </p:nvSpPr>
+        <p:spPr>
+          <a:xfrm>
+            <a:off x="3705726" y="2827105"/>
+            <a:ext cx="1058779" cy="2688171"/>
+          </a:xfrm>
+          <a:prstGeom prst="rect">
+            <a:avLst/>
+          </a:prstGeom>
+          <a:noFill/>
+        </p:spPr>
+        <p:style>
+          <a:lnRef idx="2">
+            <a:schemeClr val="accent1"/>
+          </a:lnRef>
+          <a:fillRef idx="1">
+            <a:schemeClr val="lt1"/>
+          </a:fillRef>
+          <a:effectRef idx="0">
+            <a:schemeClr val="accent1"/>
+          </a:effectRef>
+          <a:fontRef idx="minor">
+            <a:schemeClr val="dk1"/>
+          </a:fontRef>
+        </p:style>
+        <p:txBody>
+          <a:bodyPr rtlCol="0" anchor="ctr"/>
+          <a:lstStyle/>
+          <a:p>
+            <a:pPr algn="ctr"/>
+            <a:endParaRPr lang="fr-FR"/>
+          </a:p>
+        </p:txBody>
+      </p:sp>
+      <p:sp>
+        <p:nvSpPr>
+          <p:cNvPr id="11" name="Légende à une bordure 1 10">
+            <a:extLst>
+              <a:ext uri="{FF2B5EF4-FFF2-40B4-BE49-F238E27FC236}">
+                <a16:creationId xmlns:a16="http://schemas.microsoft.com/office/drawing/2014/main" id="{AA7E1BCE-7A5F-7CDC-5AF2-A997DED90335}"/>
+              </a:ext>
+            </a:extLst>
+          </p:cNvPr>
+          <p:cNvSpPr/>
+          <p:nvPr/>
+        </p:nvSpPr>
+        <p:spPr>
+          <a:xfrm>
+            <a:off x="1122145" y="3856505"/>
+            <a:ext cx="1992430" cy="1155667"/>
+          </a:xfrm>
+          <a:prstGeom prst="accentCallout1">
+            <a:avLst>
+              <a:gd name="adj1" fmla="val 22082"/>
+              <a:gd name="adj2" fmla="val 104710"/>
+              <a:gd name="adj3" fmla="val 8391"/>
+              <a:gd name="adj4" fmla="val 126401"/>
+            </a:avLst>
+          </a:prstGeom>
+        </p:spPr>
+        <p:style>
+          <a:lnRef idx="2">
+            <a:schemeClr val="accent1">
+              <a:shade val="15000"/>
+            </a:schemeClr>
+          </a:lnRef>
+          <a:fillRef idx="1">
+            <a:schemeClr val="accent1"/>
+          </a:fillRef>
+          <a:effectRef idx="0">
+            <a:schemeClr val="accent1"/>
+          </a:effectRef>
+          <a:fontRef idx="minor">
+            <a:schemeClr val="lt1"/>
+          </a:fontRef>
+        </p:style>
+        <p:txBody>
+          <a:bodyPr rtlCol="0" anchor="ctr"/>
+          <a:lstStyle/>
+          <a:p>
+            <a:pPr algn="ctr"/>
+            <a:r>
+              <a:rPr lang="fr-FR" dirty="0" err="1"/>
+              <a:t>Dendrogram</a:t>
+            </a:r>
+            <a:r>
+              <a:rPr lang="fr-FR" dirty="0"/>
+              <a:t> of the </a:t>
+            </a:r>
+            <a:r>
+              <a:rPr lang="fr-FR" dirty="0" err="1"/>
+              <a:t>rows</a:t>
+            </a:r>
+            <a:endParaRPr lang="fr-FR" dirty="0"/>
+          </a:p>
+        </p:txBody>
+      </p:sp>
+      <p:sp>
+        <p:nvSpPr>
+          <p:cNvPr id="12" name="Rectangle 11">
+            <a:extLst>
+              <a:ext uri="{FF2B5EF4-FFF2-40B4-BE49-F238E27FC236}">
+                <a16:creationId xmlns:a16="http://schemas.microsoft.com/office/drawing/2014/main" id="{F697857F-C08D-9F89-993E-204BD6FCA902}"/>
+              </a:ext>
+            </a:extLst>
+          </p:cNvPr>
+          <p:cNvSpPr/>
+          <p:nvPr/>
+        </p:nvSpPr>
+        <p:spPr>
+          <a:xfrm>
+            <a:off x="7040077" y="2781702"/>
+            <a:ext cx="423511" cy="2688170"/>
+          </a:xfrm>
+          <a:prstGeom prst="rect">
+            <a:avLst/>
+          </a:prstGeom>
+          <a:noFill/>
+        </p:spPr>
+        <p:style>
+          <a:lnRef idx="2">
+            <a:schemeClr val="accent1"/>
+          </a:lnRef>
+          <a:fillRef idx="1">
+            <a:schemeClr val="lt1"/>
+          </a:fillRef>
+          <a:effectRef idx="0">
+            <a:schemeClr val="accent1"/>
+          </a:effectRef>
+          <a:fontRef idx="minor">
+            <a:schemeClr val="dk1"/>
+          </a:fontRef>
+        </p:style>
+        <p:txBody>
+          <a:bodyPr rtlCol="0" anchor="ctr"/>
+          <a:lstStyle/>
+          <a:p>
+            <a:pPr algn="ctr"/>
+            <a:endParaRPr lang="fr-FR"/>
+          </a:p>
+        </p:txBody>
+      </p:sp>
+      <p:sp>
+        <p:nvSpPr>
+          <p:cNvPr id="13" name="Légende à une bordure 1 12">
+            <a:extLst>
+              <a:ext uri="{FF2B5EF4-FFF2-40B4-BE49-F238E27FC236}">
+                <a16:creationId xmlns:a16="http://schemas.microsoft.com/office/drawing/2014/main" id="{071BBA01-3001-E324-B46E-BCFB4C5F892E}"/>
+              </a:ext>
+            </a:extLst>
+          </p:cNvPr>
+          <p:cNvSpPr/>
+          <p:nvPr/>
+        </p:nvSpPr>
+        <p:spPr>
+          <a:xfrm>
+            <a:off x="8267299" y="3015523"/>
+            <a:ext cx="1992430" cy="1155667"/>
+          </a:xfrm>
+          <a:prstGeom prst="accentCallout1">
+            <a:avLst>
+              <a:gd name="adj1" fmla="val 90377"/>
+              <a:gd name="adj2" fmla="val -5917"/>
+              <a:gd name="adj3" fmla="val 94176"/>
+              <a:gd name="adj4" fmla="val -40265"/>
+            </a:avLst>
+          </a:prstGeom>
+        </p:spPr>
+        <p:style>
+          <a:lnRef idx="2">
+            <a:schemeClr val="accent1">
+              <a:shade val="15000"/>
+            </a:schemeClr>
+          </a:lnRef>
+          <a:fillRef idx="1">
+            <a:schemeClr val="accent1"/>
+          </a:fillRef>
+          <a:effectRef idx="0">
+            <a:schemeClr val="accent1"/>
+          </a:effectRef>
+          <a:fontRef idx="minor">
+            <a:schemeClr val="lt1"/>
+          </a:fontRef>
+        </p:style>
+        <p:txBody>
+          <a:bodyPr rtlCol="0" anchor="ctr"/>
+          <a:lstStyle/>
+          <a:p>
+            <a:pPr algn="ctr"/>
+            <a:r>
+              <a:rPr lang="fr-FR" dirty="0" err="1"/>
+              <a:t>Legend</a:t>
+            </a:r>
+            <a:r>
+              <a:rPr lang="fr-FR" dirty="0"/>
+              <a:t> (</a:t>
+            </a:r>
+            <a:r>
+              <a:rPr lang="fr-FR" dirty="0" err="1"/>
+              <a:t>color</a:t>
+            </a:r>
+            <a:r>
+              <a:rPr lang="fr-FR" dirty="0"/>
+              <a:t> of the </a:t>
+            </a:r>
+            <a:r>
+              <a:rPr lang="fr-FR" dirty="0" err="1"/>
+              <a:t>cells</a:t>
+            </a:r>
+            <a:r>
+              <a:rPr lang="fr-FR" dirty="0"/>
+              <a:t>)</a:t>
+            </a:r>
+          </a:p>
+        </p:txBody>
+      </p:sp>
+    </p:spTree>
+    <p:extLst>
+      <p:ext uri="{BB962C8B-B14F-4D97-AF65-F5344CB8AC3E}">
+        <p14:creationId xmlns:p14="http://schemas.microsoft.com/office/powerpoint/2010/main" val="1968271624"/>
+      </p:ext>
+    </p:extLst>
+  </p:cSld>
+  <p:clrMapOvr>
+    <a:masterClrMapping/>
+  </p:clrMapOvr>
+  <p:timing>
+    <p:tnLst>
+      <p:par>
+        <p:cTn id="1" dur="indefinite" restart="never" nodeType="tmRoot">
+          <p:childTnLst>
+            <p:seq concurrent="1" nextAc="seek">
+              <p:cTn id="2" dur="indefinite" nodeType="mainSeq">
+                <p:childTnLst>
+                  <p:par>
+                    <p:cTn id="3" fill="hold">
+                      <p:stCondLst>
+                        <p:cond delay="indefinite"/>
+                      </p:stCondLst>
+                      <p:childTnLst>
+                        <p:par>
+                          <p:cTn id="4" fill="hold">
+                            <p:stCondLst>
+                              <p:cond delay="0"/>
+                            </p:stCondLst>
+                            <p:childTnLst>
+                              <p:par>
+                                <p:cTn id="5" presetID="1" presetClass="entr" presetSubtype="0" fill="hold" grpId="0" nodeType="clickEffect">
+                                  <p:stCondLst>
+                                    <p:cond delay="0"/>
+                                  </p:stCondLst>
+                                  <p:childTnLst>
+                                    <p:set>
+                                      <p:cBhvr>
+                                        <p:cTn id="6" dur="1" fill="hold">
+                                          <p:stCondLst>
+                                            <p:cond delay="0"/>
+                                          </p:stCondLst>
+                                        </p:cTn>
+                                        <p:tgtEl>
+                                          <p:spTgt spid="9"/>
+                                        </p:tgtEl>
+                                        <p:attrNameLst>
+                                          <p:attrName>style.visibility</p:attrName>
+                                        </p:attrNameLst>
+                                      </p:cBhvr>
+                                      <p:to>
+                                        <p:strVal val="visible"/>
+                                      </p:to>
+                                    </p:set>
+                                  </p:childTnLst>
+                                </p:cTn>
+                              </p:par>
+                              <p:par>
+                                <p:cTn id="7" presetID="1" presetClass="entr" presetSubtype="0" fill="hold" grpId="0" nodeType="withEffect">
+                                  <p:stCondLst>
+                                    <p:cond delay="0"/>
+                                  </p:stCondLst>
+                                  <p:childTnLst>
+                                    <p:set>
+                                      <p:cBhvr>
+                                        <p:cTn id="8" dur="1" fill="hold">
+                                          <p:stCondLst>
+                                            <p:cond delay="0"/>
+                                          </p:stCondLst>
+                                        </p:cTn>
+                                        <p:tgtEl>
+                                          <p:spTgt spid="8"/>
+                                        </p:tgtEl>
+                                        <p:attrNameLst>
+                                          <p:attrName>style.visibility</p:attrName>
+                                        </p:attrNameLst>
+                                      </p:cBhvr>
+                                      <p:to>
+                                        <p:strVal val="visible"/>
+                                      </p:to>
+                                    </p:set>
+                                  </p:childTnLst>
+                                </p:cTn>
+                              </p:par>
+                            </p:childTnLst>
+                          </p:cTn>
+                        </p:par>
+                      </p:childTnLst>
+                    </p:cTn>
+                  </p:par>
+                  <p:par>
+                    <p:cTn id="9" fill="hold">
+                      <p:stCondLst>
+                        <p:cond delay="indefinite"/>
+                      </p:stCondLst>
+                      <p:childTnLst>
+                        <p:par>
+                          <p:cTn id="10" fill="hold">
+                            <p:stCondLst>
+                              <p:cond delay="0"/>
+                            </p:stCondLst>
+                            <p:childTnLst>
+                              <p:par>
+                                <p:cTn id="11" presetID="1" presetClass="entr" presetSubtype="0" fill="hold" grpId="0" nodeType="clickEffect">
+                                  <p:stCondLst>
+                                    <p:cond delay="0"/>
+                                  </p:stCondLst>
+                                  <p:childTnLst>
+                                    <p:set>
+                                      <p:cBhvr>
+                                        <p:cTn id="12" dur="1" fill="hold">
+                                          <p:stCondLst>
+                                            <p:cond delay="0"/>
+                                          </p:stCondLst>
+                                        </p:cTn>
+                                        <p:tgtEl>
+                                          <p:spTgt spid="10"/>
+                                        </p:tgtEl>
+                                        <p:attrNameLst>
+                                          <p:attrName>style.visibility</p:attrName>
+                                        </p:attrNameLst>
+                                      </p:cBhvr>
+                                      <p:to>
+                                        <p:strVal val="visible"/>
+                                      </p:to>
+                                    </p:set>
+                                  </p:childTnLst>
+                                </p:cTn>
+                              </p:par>
+                              <p:par>
+                                <p:cTn id="13" presetID="1" presetClass="entr" presetSubtype="0" fill="hold" grpId="0" nodeType="withEffect">
+                                  <p:stCondLst>
+                                    <p:cond delay="0"/>
+                                  </p:stCondLst>
+                                  <p:childTnLst>
+                                    <p:set>
+                                      <p:cBhvr>
+                                        <p:cTn id="14" dur="1" fill="hold">
+                                          <p:stCondLst>
+                                            <p:cond delay="0"/>
+                                          </p:stCondLst>
+                                        </p:cTn>
+                                        <p:tgtEl>
+                                          <p:spTgt spid="11"/>
+                                        </p:tgtEl>
+                                        <p:attrNameLst>
+                                          <p:attrName>style.visibility</p:attrName>
+                                        </p:attrNameLst>
+                                      </p:cBhvr>
+                                      <p:to>
+                                        <p:strVal val="visible"/>
+                                      </p:to>
+                                    </p:set>
+                                  </p:childTnLst>
+                                </p:cTn>
+                              </p:par>
+                            </p:childTnLst>
+                          </p:cTn>
+                        </p:par>
+                      </p:childTnLst>
+                    </p:cTn>
+                  </p:par>
+                  <p:par>
+                    <p:cTn id="15" fill="hold">
+                      <p:stCondLst>
+                        <p:cond delay="indefinite"/>
+                      </p:stCondLst>
+                      <p:childTnLst>
+                        <p:par>
+                          <p:cTn id="16" fill="hold">
+                            <p:stCondLst>
+                              <p:cond delay="0"/>
+                            </p:stCondLst>
+                            <p:childTnLst>
+                              <p:par>
+                                <p:cTn id="17" presetID="1" presetClass="entr" presetSubtype="0" fill="hold" grpId="0" nodeType="clickEffect">
+                                  <p:stCondLst>
+                                    <p:cond delay="0"/>
+                                  </p:stCondLst>
+                                  <p:childTnLst>
+                                    <p:set>
+                                      <p:cBhvr>
+                                        <p:cTn id="18" dur="1" fill="hold">
+                                          <p:stCondLst>
+                                            <p:cond delay="0"/>
+                                          </p:stCondLst>
+                                        </p:cTn>
+                                        <p:tgtEl>
+                                          <p:spTgt spid="12"/>
+                                        </p:tgtEl>
+                                        <p:attrNameLst>
+                                          <p:attrName>style.visibility</p:attrName>
+                                        </p:attrNameLst>
+                                      </p:cBhvr>
+                                      <p:to>
+                                        <p:strVal val="visible"/>
+                                      </p:to>
+                                    </p:set>
+                                  </p:childTnLst>
+                                </p:cTn>
+                              </p:par>
+                              <p:par>
+                                <p:cTn id="19" presetID="1" presetClass="entr" presetSubtype="0" fill="hold" grpId="0" nodeType="withEffect">
+                                  <p:stCondLst>
+                                    <p:cond delay="0"/>
+                                  </p:stCondLst>
+                                  <p:childTnLst>
+                                    <p:set>
+                                      <p:cBhvr>
+                                        <p:cTn id="20" dur="1" fill="hold">
+                                          <p:stCondLst>
+                                            <p:cond delay="0"/>
+                                          </p:stCondLst>
+                                        </p:cTn>
+                                        <p:tgtEl>
+                                          <p:spTgt spid="13"/>
+                                        </p:tgtEl>
+                                        <p:attrNameLst>
+                                          <p:attrName>style.visibility</p:attrName>
+                                        </p:attrNameLst>
+                                      </p:cBhvr>
+                                      <p:to>
+                                        <p:strVal val="visible"/>
+                                      </p:to>
+                                    </p:set>
+                                  </p:childTnLst>
+                                </p:cTn>
+                              </p:par>
+                            </p:childTnLst>
+                          </p:cTn>
+                        </p:par>
+                      </p:childTnLst>
+                    </p:cTn>
+                  </p:par>
+                </p:childTnLst>
+              </p:cTn>
+              <p:prevCondLst>
+                <p:cond evt="onPrev" delay="0">
+                  <p:tgtEl>
+                    <p:sldTgt/>
+                  </p:tgtEl>
+                </p:cond>
+              </p:prevCondLst>
+              <p:nextCondLst>
+                <p:cond evt="onNext" delay="0">
+                  <p:tgtEl>
+                    <p:sldTgt/>
+                  </p:tgtEl>
+                </p:cond>
+              </p:nextCondLst>
+            </p:seq>
+          </p:childTnLst>
+        </p:cTn>
+      </p:par>
+    </p:tnLst>
+    <p:bldLst>
+      <p:bldP spid="8" grpId="0" animBg="1"/>
+      <p:bldP spid="9" grpId="0" animBg="1"/>
+      <p:bldP spid="10" grpId="0" animBg="1"/>
+      <p:bldP spid="11" grpId="0" animBg="1"/>
+      <p:bldP spid="12" grpId="0" animBg="1"/>
+      <p:bldP spid="13" grpId="0" animBg="1"/>
+    </p:bldLst>
+  </p:timing>
+</p:sld>
+</file>
+
+<file path=ppt/slides/slide9.xml><?xml version="1.0" encoding="utf-8"?>
+<p:sld xmlns:a="http://schemas.openxmlformats.org/drawingml/2006/main" xmlns:r="http://schemas.openxmlformats.org/officeDocument/2006/relationships" xmlns:p="http://schemas.openxmlformats.org/presentationml/2006/main">
+  <p:cSld>
+    <p:spTree>
+      <p:nvGrpSpPr>
+        <p:cNvPr id="1" name=""/>
+        <p:cNvGrpSpPr/>
+        <p:nvPr/>
+      </p:nvGrpSpPr>
+      <p:grpSpPr>
+        <a:xfrm>
+          <a:off x="0" y="0"/>
+          <a:ext cx="0" cy="0"/>
+          <a:chOff x="0" y="0"/>
+          <a:chExt cx="0" cy="0"/>
+        </a:xfrm>
+      </p:grpSpPr>
+      <p:sp>
+        <p:nvSpPr>
+          <p:cNvPr id="2" name="Titre 1">
+            <a:extLst>
+              <a:ext uri="{FF2B5EF4-FFF2-40B4-BE49-F238E27FC236}">
+                <a16:creationId xmlns:a16="http://schemas.microsoft.com/office/drawing/2014/main" id="{1AED3AD3-3FC3-56C0-2111-6D8C788A6AA3}"/>
+              </a:ext>
+            </a:extLst>
+          </p:cNvPr>
+          <p:cNvSpPr>
+            <a:spLocks noGrp="1"/>
+          </p:cNvSpPr>
+          <p:nvPr>
+            <p:ph type="title"/>
+          </p:nvPr>
+        </p:nvSpPr>
+        <p:spPr/>
+        <p:txBody>
+          <a:bodyPr/>
+          <a:lstStyle/>
+          <a:p>
+            <a:r>
+              <a:rPr lang="fr-FR" dirty="0" err="1"/>
+              <a:t>Exercise</a:t>
+            </a:r>
+            <a:endParaRPr lang="fr-FR" dirty="0"/>
+          </a:p>
+        </p:txBody>
+      </p:sp>
+      <p:sp>
+        <p:nvSpPr>
+          <p:cNvPr id="3" name="Espace réservé du contenu 2">
+            <a:extLst>
+              <a:ext uri="{FF2B5EF4-FFF2-40B4-BE49-F238E27FC236}">
+                <a16:creationId xmlns:a16="http://schemas.microsoft.com/office/drawing/2014/main" id="{0557CD32-31FC-4184-87EF-2AAC8DBB87E1}"/>
+              </a:ext>
+            </a:extLst>
+          </p:cNvPr>
+          <p:cNvSpPr>
+            <a:spLocks noGrp="1"/>
+          </p:cNvSpPr>
+          <p:nvPr>
+            <p:ph idx="1"/>
+          </p:nvPr>
+        </p:nvSpPr>
+        <p:spPr/>
+        <p:txBody>
+          <a:bodyPr/>
+          <a:lstStyle/>
+          <a:p>
+            <a:pPr marL="0" indent="0">
+              <a:buNone/>
+            </a:pPr>
+            <a:r>
+              <a:rPr lang="fr-FR" dirty="0" err="1"/>
+              <a:t>Create</a:t>
+            </a:r>
+            <a:r>
+              <a:rPr lang="fr-FR" dirty="0"/>
+              <a:t> a </a:t>
+            </a:r>
+            <a:r>
+              <a:rPr lang="fr-FR" dirty="0" err="1"/>
+              <a:t>heatmap</a:t>
+            </a:r>
+            <a:r>
+              <a:rPr lang="fr-FR" dirty="0"/>
+              <a:t> of the expression of </a:t>
+            </a:r>
+            <a:r>
+              <a:rPr lang="fr-FR" dirty="0" err="1"/>
+              <a:t>genes</a:t>
+            </a:r>
+            <a:r>
+              <a:rPr lang="fr-FR" dirty="0"/>
+              <a:t> IL1A, IL1B, IL1R1, CD4, CD8A, and CD8B.</a:t>
+            </a:r>
+          </a:p>
+          <a:p>
+            <a:endParaRPr lang="fr-FR" dirty="0"/>
+          </a:p>
+          <a:p>
+            <a:pPr marL="0" indent="0">
+              <a:buNone/>
+            </a:pPr>
+            <a:r>
+              <a:rPr lang="fr-FR" i="1" dirty="0"/>
+              <a:t>Bonus </a:t>
+            </a:r>
+            <a:r>
+              <a:rPr lang="fr-FR" i="1" dirty="0" err="1"/>
+              <a:t>constraints</a:t>
+            </a:r>
+            <a:r>
+              <a:rPr lang="fr-FR" i="1" dirty="0"/>
+              <a:t>:</a:t>
+            </a:r>
+          </a:p>
+          <a:p>
+            <a:pPr lvl="1"/>
+            <a:r>
+              <a:rPr lang="fr-FR" dirty="0"/>
+              <a:t>show cases </a:t>
+            </a:r>
+            <a:r>
+              <a:rPr lang="fr-FR" dirty="0" err="1"/>
+              <a:t>only</a:t>
+            </a:r>
+            <a:endParaRPr lang="fr-FR" dirty="0"/>
+          </a:p>
+          <a:p>
+            <a:pPr lvl="1"/>
+            <a:r>
+              <a:rPr lang="fr-FR" dirty="0"/>
+              <a:t>use Ward </a:t>
+            </a:r>
+            <a:r>
+              <a:rPr lang="fr-FR" dirty="0" err="1"/>
+              <a:t>agglomeration</a:t>
+            </a:r>
+            <a:r>
+              <a:rPr lang="fr-FR" dirty="0"/>
+              <a:t> </a:t>
+            </a:r>
+            <a:r>
+              <a:rPr lang="fr-FR" dirty="0" err="1"/>
+              <a:t>method</a:t>
+            </a:r>
+            <a:endParaRPr lang="fr-FR" dirty="0"/>
+          </a:p>
+          <a:p>
+            <a:pPr lvl="1"/>
+            <a:r>
+              <a:rPr lang="fr-FR" dirty="0"/>
+              <a:t>use a </a:t>
+            </a:r>
+            <a:r>
+              <a:rPr lang="fr-FR" dirty="0" err="1"/>
+              <a:t>correlation</a:t>
+            </a:r>
+            <a:r>
+              <a:rPr lang="fr-FR" dirty="0"/>
+              <a:t> distance on the </a:t>
+            </a:r>
+            <a:r>
+              <a:rPr lang="fr-FR" dirty="0" err="1"/>
+              <a:t>columns</a:t>
+            </a:r>
+            <a:endParaRPr lang="fr-FR" dirty="0"/>
+          </a:p>
+          <a:p>
+            <a:pPr lvl="1"/>
+            <a:r>
+              <a:rPr lang="fr-FR" dirty="0"/>
+              <a:t>change the </a:t>
+            </a:r>
+            <a:r>
+              <a:rPr lang="fr-FR" dirty="0" err="1"/>
+              <a:t>colors</a:t>
+            </a:r>
+            <a:endParaRPr lang="fr-FR" dirty="0"/>
+          </a:p>
+          <a:p>
+            <a:pPr lvl="1"/>
+            <a:r>
+              <a:rPr lang="fr-FR" dirty="0"/>
+              <a:t>….</a:t>
+            </a:r>
+          </a:p>
+        </p:txBody>
+      </p:sp>
+      <p:sp>
+        <p:nvSpPr>
+          <p:cNvPr id="4" name="Espace réservé du numéro de diapositive 3">
+            <a:extLst>
+              <a:ext uri="{FF2B5EF4-FFF2-40B4-BE49-F238E27FC236}">
+                <a16:creationId xmlns:a16="http://schemas.microsoft.com/office/drawing/2014/main" id="{6CD91EC9-66F8-BFD2-C647-B1C499DBB811}"/>
+              </a:ext>
+            </a:extLst>
+          </p:cNvPr>
+          <p:cNvSpPr>
+            <a:spLocks noGrp="1"/>
+          </p:cNvSpPr>
+          <p:nvPr>
+            <p:ph type="sldNum" sz="quarter" idx="12"/>
+          </p:nvPr>
+        </p:nvSpPr>
+        <p:spPr/>
+        <p:txBody>
+          <a:bodyPr/>
+          <a:lstStyle/>
+          <a:p>
+            <a:fld id="{D13C05C1-FA7E-DB42-9F51-FE4437F6CA80}" type="slidenum">
+              <a:rPr lang="fr-FR" smtClean="0"/>
+              <a:t>8</a:t>
+            </a:fld>
+            <a:endParaRPr lang="fr-FR"/>
+          </a:p>
+        </p:txBody>
+      </p:sp>
+    </p:spTree>
+    <p:extLst>
+      <p:ext uri="{BB962C8B-B14F-4D97-AF65-F5344CB8AC3E}">
+        <p14:creationId xmlns:p14="http://schemas.microsoft.com/office/powerpoint/2010/main" val="3137919480"/>
       </p:ext>
     </p:extLst>
   </p:cSld>

</xml_diff>